<commit_message>
README e deck atualizados para o desenho final (tratamento=envio, politica causal)
- README: enquadramento com decisoes/alternativas, execucao local + Databricks,
  resultados fora do tempo, premissas e limitacoes
- Deck 5 slides: desperdicio (~30% dos cupons sem efeito) -> efeito causal do
  envio (R$9,21 liq.) -> politica validada (top 20% = R$21 vs 0) -> impacto
  (10,3M -> 12,3M piso; teto a validar em A/B)
- Figuras antigas do desenho anterior removidas; novo funil com ordem view<=comp
- src/config.py enxugado (codigo morto do desenho antigo)

Co-Authored-By: Claude Fable 5 <noreply@anthropic.com>
</commit_message>
<xml_diff>
--- a/presentation/ifood_case.pptx
+++ b/presentation/ifood_case.pptx
@@ -3165,7 +3165,7 @@
                 </a:solidFill>
                 <a:latin typeface="Calibri"/>
               </a:rPr>
-              <a:t>iFood · Data Science — Otimização de Cupons</a:t>
+              <a:t>iFood · Data Science — Direcionamento de Cupons</a:t>
             </a:r>
           </a:p>
         </p:txBody>
@@ -3179,7 +3179,7 @@
         <p:spPr>
           <a:xfrm>
             <a:off x="822960" y="2651760"/>
-            <a:ext cx="10515600" cy="1463040"/>
+            <a:ext cx="10789920" cy="1463040"/>
           </a:xfrm>
           <a:prstGeom prst="rect">
             <a:avLst/>
@@ -3194,13 +3194,25 @@
           <a:p>
             <a:pPr algn="l"/>
             <a:r>
-              <a:rPr sz="4000" b="1">
+              <a:rPr sz="3800" b="1">
                 <a:solidFill>
                   <a:srgbClr val="2B2B2B"/>
                 </a:solidFill>
                 <a:latin typeface="Calibri"/>
               </a:rPr>
-              <a:t>Enviar a oferta certa, para o cliente certo</a:t>
+              <a:t>A oferta certa, para o cliente certo —</a:t>
+            </a:r>
+          </a:p>
+          <a:p>
+            <a:pPr algn="l"/>
+            <a:r>
+              <a:rPr sz="3800" b="1">
+                <a:solidFill>
+                  <a:srgbClr val="2B2B2B"/>
+                </a:solidFill>
+                <a:latin typeface="Calibri"/>
+              </a:rPr>
+              <a:t>e só quando ela gera venda nova</a:t>
             </a:r>
           </a:p>
         </p:txBody>
@@ -3213,7 +3225,7 @@
         </p:nvSpPr>
         <p:spPr>
           <a:xfrm>
-            <a:off x="822960" y="4206240"/>
+            <a:off x="822960" y="4480560"/>
             <a:ext cx="10515600" cy="1097280"/>
           </a:xfrm>
           <a:prstGeom prst="rect">
@@ -3229,13 +3241,25 @@
           <a:p>
             <a:pPr algn="l"/>
             <a:r>
-              <a:rPr sz="1800" b="0">
+              <a:rPr sz="1700" b="0">
                 <a:solidFill>
                   <a:srgbClr val="666666"/>
                 </a:solidFill>
                 <a:latin typeface="Calibri"/>
               </a:rPr>
-              <a:t>Uplift modeling para maximizar o retorno incremental dos cupons — parando de gastar recompensa com quem já compraria.</a:t>
+              <a:t>Medimos o efeito real de cada envio (venda incremental, descontado o cupom)</a:t>
+            </a:r>
+          </a:p>
+          <a:p>
+            <a:pPr algn="l"/>
+            <a:r>
+              <a:rPr sz="1700" b="0">
+                <a:solidFill>
+                  <a:srgbClr val="666666"/>
+                </a:solidFill>
+                <a:latin typeface="Calibri"/>
+              </a:rPr>
+              <a:t>e transformamos isso numa política de envio por cliente.</a:t>
             </a:r>
           </a:p>
         </p:txBody>
@@ -3248,8 +3272,8 @@
         </p:nvSpPr>
         <p:spPr>
           <a:xfrm>
-            <a:off x="822960" y="5852160"/>
-            <a:ext cx="10515600" cy="548640"/>
+            <a:off x="822960" y="5943600"/>
+            <a:ext cx="10515600" cy="457200"/>
           </a:xfrm>
           <a:prstGeom prst="rect">
             <a:avLst/>
@@ -3264,13 +3288,13 @@
           <a:p>
             <a:pPr algn="l"/>
             <a:r>
-              <a:rPr sz="1300" b="0">
+              <a:rPr sz="1200" b="0">
                 <a:solidFill>
                   <a:srgbClr val="666666"/>
                 </a:solidFill>
                 <a:latin typeface="Calibri"/>
               </a:rPr>
-              <a:t>Recomendação de oferta por cliente  ·  baseada em ~306 mil eventos e 17 mil clientes</a:t>
+              <a:t>Base: 17 mil clientes · 306 mil eventos · 76 mil envios em 6 campanhas</a:t>
             </a:r>
           </a:p>
         </p:txBody>
@@ -3380,7 +3404,7 @@
         <p:spPr>
           <a:xfrm>
             <a:off x="640080" y="777240"/>
-            <a:ext cx="10972800" cy="822960"/>
+            <a:ext cx="11155680" cy="822960"/>
           </a:xfrm>
           <a:prstGeom prst="rect">
             <a:avLst/>
@@ -3395,20 +3419,20 @@
           <a:p>
             <a:pPr algn="l"/>
             <a:r>
-              <a:rPr sz="2800" b="1">
+              <a:rPr sz="2700" b="1">
                 <a:solidFill>
                   <a:srgbClr val="2B2B2B"/>
                 </a:solidFill>
                 <a:latin typeface="Calibri"/>
               </a:rPr>
-              <a:t>Hoje parte do orçamento de cupons é desperdiçada</a:t>
+              <a:t>Parte do orçamento de cupons não gera venda nova</a:t>
             </a:r>
           </a:p>
         </p:txBody>
       </p:sp>
       <p:pic>
         <p:nvPicPr>
-          <p:cNvPr id="5" name="Picture 4" descr="01_funnel.png"/>
+          <p:cNvPr id="5" name="Picture 4" descr="10_funnel.png"/>
           <p:cNvPicPr>
             <a:picLocks noChangeAspect="1"/>
           </p:cNvPicPr>
@@ -3423,7 +3447,7 @@
         <p:spPr>
           <a:xfrm>
             <a:off x="548640" y="1828800"/>
-            <a:ext cx="6675120" cy="2979341"/>
+            <a:ext cx="6583680" cy="2874565"/>
           </a:xfrm>
           <a:prstGeom prst="rect">
             <a:avLst/>
@@ -3438,8 +3462,8 @@
         </p:nvSpPr>
         <p:spPr>
           <a:xfrm>
-            <a:off x="7498079" y="1920240"/>
-            <a:ext cx="4206240" cy="4114800"/>
+            <a:off x="7406640" y="1920240"/>
+            <a:ext cx="4389120" cy="822960"/>
           </a:xfrm>
           <a:prstGeom prst="rect">
             <a:avLst/>
@@ -3454,25 +3478,25 @@
           <a:p>
             <a:pPr algn="l"/>
             <a:r>
-              <a:rPr sz="2200" b="1">
+              <a:rPr sz="2100" b="1">
                 <a:solidFill>
                   <a:srgbClr val="EA1D2C"/>
                 </a:solidFill>
                 <a:latin typeface="Calibri"/>
               </a:rPr>
-              <a:t>1 em cada 10 cupons</a:t>
-            </a:r>
-          </a:p>
-          <a:p>
-            <a:pPr algn="l"/>
-            <a:r>
-              <a:rPr sz="2200" b="1">
+              <a:t>~30% dos cupons pagos</a:t>
+            </a:r>
+          </a:p>
+          <a:p>
+            <a:pPr algn="l"/>
+            <a:r>
+              <a:rPr sz="2100" b="1">
                 <a:solidFill>
                   <a:srgbClr val="EA1D2C"/>
                 </a:solidFill>
                 <a:latin typeface="Calibri"/>
               </a:rPr>
-              <a:t>é completado SEM ser visto</a:t>
+              <a:t>não influenciaram a compra</a:t>
             </a:r>
           </a:p>
         </p:txBody>
@@ -3485,8 +3509,8 @@
         </p:nvSpPr>
         <p:spPr>
           <a:xfrm>
-            <a:off x="7498079" y="2926080"/>
-            <a:ext cx="4297680" cy="3657600"/>
+            <a:off x="7406640" y="3200400"/>
+            <a:ext cx="4480560" cy="2926080"/>
           </a:xfrm>
           <a:prstGeom prst="rect">
             <a:avLst/>
@@ -3507,7 +3531,7 @@
                 </a:solidFill>
                 <a:latin typeface="Calibri"/>
               </a:rPr>
-              <a:t>→ O cliente compraria de qualquer forma.</a:t>
+              <a:t>O cliente atingiu o valor mínimo e o</a:t>
             </a:r>
           </a:p>
           <a:p>
@@ -3519,7 +3543,7 @@
                 </a:solidFill>
                 <a:latin typeface="Calibri"/>
               </a:rPr>
-              <a:t>   A recompensa é dinheiro jogado fora.</a:t>
+              <a:t>cupom foi resgatado sem que ele</a:t>
             </a:r>
           </a:p>
           <a:p>
@@ -3531,6 +3555,30 @@
                 </a:solidFill>
                 <a:latin typeface="Calibri"/>
               </a:rPr>
+              <a:t>tivesse visto a oferta — a compra</a:t>
+            </a:r>
+          </a:p>
+          <a:p>
+            <a:pPr algn="l"/>
+            <a:r>
+              <a:rPr sz="1500" b="0">
+                <a:solidFill>
+                  <a:srgbClr val="2B2B2B"/>
+                </a:solidFill>
+                <a:latin typeface="Calibri"/>
+              </a:rPr>
+              <a:t>aconteceria de qualquer forma.</a:t>
+            </a:r>
+          </a:p>
+          <a:p>
+            <a:pPr algn="l"/>
+            <a:r>
+              <a:rPr sz="1500" b="0">
+                <a:solidFill>
+                  <a:srgbClr val="2B2B2B"/>
+                </a:solidFill>
+                <a:latin typeface="Calibri"/>
+              </a:rPr>
               <a:t/>
             </a:r>
           </a:p>
@@ -3543,7 +3591,7 @@
                 </a:solidFill>
                 <a:latin typeface="Calibri"/>
               </a:rPr>
-              <a:t>Além disso, 31% veem o cupom e não</a:t>
+              <a:t>Enviar a mesma oferta para todos</a:t>
             </a:r>
           </a:p>
           <a:p>
@@ -3555,43 +3603,7 @@
                 </a:solidFill>
                 <a:latin typeface="Calibri"/>
               </a:rPr>
-              <a:t>usam — mídia gasta sem retorno.</a:t>
-            </a:r>
-          </a:p>
-          <a:p>
-            <a:pPr algn="l"/>
-            <a:r>
-              <a:rPr sz="1500" b="0">
-                <a:solidFill>
-                  <a:srgbClr val="2B2B2B"/>
-                </a:solidFill>
-                <a:latin typeface="Calibri"/>
-              </a:rPr>
-              <a:t/>
-            </a:r>
-          </a:p>
-          <a:p>
-            <a:pPr algn="l"/>
-            <a:r>
-              <a:rPr sz="1500" b="0">
-                <a:solidFill>
-                  <a:srgbClr val="2B2B2B"/>
-                </a:solidFill>
-                <a:latin typeface="Calibri"/>
-              </a:rPr>
-              <a:t>Enviar para todo mundo não é a</a:t>
-            </a:r>
-          </a:p>
-          <a:p>
-            <a:pPr algn="l"/>
-            <a:r>
-              <a:rPr sz="1500" b="0">
-                <a:solidFill>
-                  <a:srgbClr val="2B2B2B"/>
-                </a:solidFill>
-                <a:latin typeface="Calibri"/>
-              </a:rPr>
-              <a:t>estratégia mais rentável.</a:t>
+              <a:t>ignora quem responde e quem não.</a:t>
             </a:r>
           </a:p>
         </p:txBody>
@@ -3687,7 +3699,7 @@
                 </a:solidFill>
                 <a:latin typeface="Calibri"/>
               </a:rPr>
-              <a:t>A solução</a:t>
+              <a:t>Quanto vale um envio</a:t>
             </a:r>
           </a:p>
         </p:txBody>
@@ -3701,7 +3713,7 @@
         <p:spPr>
           <a:xfrm>
             <a:off x="640080" y="777240"/>
-            <a:ext cx="10972800" cy="822960"/>
+            <a:ext cx="11155680" cy="822960"/>
           </a:xfrm>
           <a:prstGeom prst="rect">
             <a:avLst/>
@@ -3716,198 +3728,20 @@
           <a:p>
             <a:pPr algn="l"/>
             <a:r>
-              <a:rPr sz="2800" b="1">
+              <a:rPr sz="2700" b="1">
                 <a:solidFill>
                   <a:srgbClr val="2B2B2B"/>
                 </a:solidFill>
                 <a:latin typeface="Calibri"/>
               </a:rPr>
-              <a:t>Prever o efeito INCREMENTAL de cada oferta (uplift)</a:t>
-            </a:r>
-          </a:p>
-        </p:txBody>
-      </p:sp>
-      <p:sp>
-        <p:nvSpPr>
-          <p:cNvPr id="5" name="TextBox 4"/>
-          <p:cNvSpPr txBox="1"/>
-          <p:nvPr/>
-        </p:nvSpPr>
-        <p:spPr>
-          <a:xfrm>
-            <a:off x="640080" y="1645920"/>
-            <a:ext cx="5486400" cy="3108960"/>
-          </a:xfrm>
-          <a:prstGeom prst="rect">
-            <a:avLst/>
-          </a:prstGeom>
-          <a:noFill/>
-        </p:spPr>
-        <p:txBody>
-          <a:bodyPr wrap="square">
-            <a:spAutoFit/>
-          </a:bodyPr>
-          <a:lstStyle/>
-          <a:p>
-            <a:pPr algn="l"/>
-            <a:r>
-              <a:rPr sz="1600" b="0">
-                <a:solidFill>
-                  <a:srgbClr val="2B2B2B"/>
-                </a:solidFill>
-                <a:latin typeface="Calibri"/>
-              </a:rPr>
-              <a:t>Em vez de prever quem completa,</a:t>
-            </a:r>
-          </a:p>
-          <a:p>
-            <a:pPr algn="l"/>
-            <a:r>
-              <a:rPr sz="1600" b="0">
-                <a:solidFill>
-                  <a:srgbClr val="2B2B2B"/>
-                </a:solidFill>
-                <a:latin typeface="Calibri"/>
-              </a:rPr>
-              <a:t>prevemos quanto a oferta MUDA o</a:t>
-            </a:r>
-          </a:p>
-          <a:p>
-            <a:pPr algn="l"/>
-            <a:r>
-              <a:rPr sz="1600" b="0">
-                <a:solidFill>
-                  <a:srgbClr val="2B2B2B"/>
-                </a:solidFill>
-                <a:latin typeface="Calibri"/>
-              </a:rPr>
-              <a:t>comportamento de cada cliente.</a:t>
-            </a:r>
-          </a:p>
-          <a:p>
-            <a:pPr algn="l"/>
-            <a:r>
-              <a:rPr sz="1600" b="0">
-                <a:solidFill>
-                  <a:srgbClr val="2B2B2B"/>
-                </a:solidFill>
-                <a:latin typeface="Calibri"/>
-              </a:rPr>
-              <a:t/>
-            </a:r>
-          </a:p>
-          <a:p>
-            <a:pPr algn="l"/>
-            <a:r>
-              <a:rPr sz="1600" b="0">
-                <a:solidFill>
-                  <a:srgbClr val="2B2B2B"/>
-                </a:solidFill>
-                <a:latin typeface="Calibri"/>
-              </a:rPr>
-              <a:t>Isso separa 3 grupos:</a:t>
-            </a:r>
-          </a:p>
-          <a:p>
-            <a:pPr algn="l"/>
-            <a:r>
-              <a:rPr sz="1600" b="0">
-                <a:solidFill>
-                  <a:srgbClr val="2B2B2B"/>
-                </a:solidFill>
-                <a:latin typeface="Calibri"/>
-              </a:rPr>
-              <a:t/>
-            </a:r>
-          </a:p>
-          <a:p>
-            <a:pPr algn="l"/>
-            <a:r>
-              <a:rPr sz="1600" b="0">
-                <a:solidFill>
-                  <a:srgbClr val="2B2B2B"/>
-                </a:solidFill>
-                <a:latin typeface="Calibri"/>
-              </a:rPr>
-              <a:t>•  Persuadíveis → ENVIAR</a:t>
-            </a:r>
-          </a:p>
-          <a:p>
-            <a:pPr algn="l"/>
-            <a:r>
-              <a:rPr sz="1600" b="0">
-                <a:solidFill>
-                  <a:srgbClr val="2B2B2B"/>
-                </a:solidFill>
-                <a:latin typeface="Calibri"/>
-              </a:rPr>
-              <a:t>•  Já comprariam → NÃO enviar (economia)</a:t>
-            </a:r>
-          </a:p>
-          <a:p>
-            <a:pPr algn="l"/>
-            <a:r>
-              <a:rPr sz="1600" b="0">
-                <a:solidFill>
-                  <a:srgbClr val="2B2B2B"/>
-                </a:solidFill>
-                <a:latin typeface="Calibri"/>
-              </a:rPr>
-              <a:t>•  Não respondem → NÃO enviar</a:t>
-            </a:r>
-          </a:p>
-        </p:txBody>
-      </p:sp>
-      <p:sp>
-        <p:nvSpPr>
-          <p:cNvPr id="6" name="TextBox 5"/>
-          <p:cNvSpPr txBox="1"/>
-          <p:nvPr/>
-        </p:nvSpPr>
-        <p:spPr>
-          <a:xfrm>
-            <a:off x="640080" y="4937760"/>
-            <a:ext cx="5669280" cy="1371600"/>
-          </a:xfrm>
-          <a:prstGeom prst="rect">
-            <a:avLst/>
-          </a:prstGeom>
-          <a:noFill/>
-        </p:spPr>
-        <p:txBody>
-          <a:bodyPr wrap="square">
-            <a:spAutoFit/>
-          </a:bodyPr>
-          <a:lstStyle/>
-          <a:p>
-            <a:pPr algn="l"/>
-            <a:r>
-              <a:rPr sz="1500" b="1">
-                <a:solidFill>
-                  <a:srgbClr val="EA1D2C"/>
-                </a:solidFill>
-                <a:latin typeface="Calibri"/>
-              </a:rPr>
-              <a:t>Descoberta: cupons de DESCONTO têm uplift</a:t>
-            </a:r>
-          </a:p>
-          <a:p>
-            <a:pPr algn="l"/>
-            <a:r>
-              <a:rPr sz="1500" b="1">
-                <a:solidFill>
-                  <a:srgbClr val="EA1D2C"/>
-                </a:solidFill>
-                <a:latin typeface="Calibri"/>
-              </a:rPr>
-              <a:t>~4x maior que BOGO (+29 vs +8 p.p.).</a:t>
+              <a:t>Cada envio gera, em média, R$ 9 de venda nova — já descontado o cupom</a:t>
             </a:r>
           </a:p>
         </p:txBody>
       </p:sp>
       <p:pic>
         <p:nvPicPr>
-          <p:cNvPr id="7" name="Picture 6" descr="02_uplift_segments.png"/>
+          <p:cNvPr id="5" name="Picture 4" descr="05_ate.png"/>
           <p:cNvPicPr>
             <a:picLocks noChangeAspect="1"/>
           </p:cNvPicPr>
@@ -3921,14 +3755,204 @@
         </p:blipFill>
         <p:spPr>
           <a:xfrm>
-            <a:off x="6309360" y="2011680"/>
-            <a:ext cx="5577840" cy="1688704"/>
+            <a:off x="548640" y="1828800"/>
+            <a:ext cx="6217920" cy="3206115"/>
           </a:xfrm>
           <a:prstGeom prst="rect">
             <a:avLst/>
           </a:prstGeom>
         </p:spPr>
       </p:pic>
+      <p:sp>
+        <p:nvSpPr>
+          <p:cNvPr id="6" name="TextBox 5"/>
+          <p:cNvSpPr txBox="1"/>
+          <p:nvPr/>
+        </p:nvSpPr>
+        <p:spPr>
+          <a:xfrm>
+            <a:off x="7040880" y="1920240"/>
+            <a:ext cx="4754880" cy="731520"/>
+          </a:xfrm>
+          <a:prstGeom prst="rect">
+            <a:avLst/>
+          </a:prstGeom>
+          <a:noFill/>
+        </p:spPr>
+        <p:txBody>
+          <a:bodyPr wrap="square">
+            <a:spAutoFit/>
+          </a:bodyPr>
+          <a:lstStyle/>
+          <a:p>
+            <a:pPr algn="l"/>
+            <a:r>
+              <a:rPr sz="1600" b="1">
+                <a:solidFill>
+                  <a:srgbClr val="2B2B2B"/>
+                </a:solidFill>
+                <a:latin typeface="Calibri"/>
+              </a:rPr>
+              <a:t>Como medimos</a:t>
+            </a:r>
+          </a:p>
+        </p:txBody>
+      </p:sp>
+      <p:sp>
+        <p:nvSpPr>
+          <p:cNvPr id="7" name="TextBox 6"/>
+          <p:cNvSpPr txBox="1"/>
+          <p:nvPr/>
+        </p:nvSpPr>
+        <p:spPr>
+          <a:xfrm>
+            <a:off x="7040880" y="2468880"/>
+            <a:ext cx="4846320" cy="3291840"/>
+          </a:xfrm>
+          <a:prstGeom prst="rect">
+            <a:avLst/>
+          </a:prstGeom>
+          <a:noFill/>
+        </p:spPr>
+        <p:txBody>
+          <a:bodyPr wrap="square">
+            <a:spAutoFit/>
+          </a:bodyPr>
+          <a:lstStyle/>
+          <a:p>
+            <a:pPr algn="l"/>
+            <a:r>
+              <a:rPr sz="1400" b="0">
+                <a:solidFill>
+                  <a:srgbClr val="2B2B2B"/>
+                </a:solidFill>
+                <a:latin typeface="Calibri"/>
+              </a:rPr>
+              <a:t>Em cada campanha, ~25% dos clientes</a:t>
+            </a:r>
+          </a:p>
+          <a:p>
+            <a:pPr algn="l"/>
+            <a:r>
+              <a:rPr sz="1400" b="0">
+                <a:solidFill>
+                  <a:srgbClr val="2B2B2B"/>
+                </a:solidFill>
+                <a:latin typeface="Calibri"/>
+              </a:rPr>
+              <a:t>não receberam oferta — um grupo de</a:t>
+            </a:r>
+          </a:p>
+          <a:p>
+            <a:pPr algn="l"/>
+            <a:r>
+              <a:rPr sz="1400" b="0">
+                <a:solidFill>
+                  <a:srgbClr val="2B2B2B"/>
+                </a:solidFill>
+                <a:latin typeface="Calibri"/>
+              </a:rPr>
+              <a:t>comparação equivalente aos demais.</a:t>
+            </a:r>
+          </a:p>
+          <a:p>
+            <a:pPr algn="l"/>
+            <a:r>
+              <a:rPr sz="1400" b="0">
+                <a:solidFill>
+                  <a:srgbClr val="2B2B2B"/>
+                </a:solidFill>
+                <a:latin typeface="Calibri"/>
+              </a:rPr>
+              <a:t/>
+            </a:r>
+          </a:p>
+          <a:p>
+            <a:pPr algn="l"/>
+            <a:r>
+              <a:rPr sz="1400" b="0">
+                <a:solidFill>
+                  <a:srgbClr val="2B2B2B"/>
+                </a:solidFill>
+                <a:latin typeface="Calibri"/>
+              </a:rPr>
+              <a:t>A diferença entre os dois grupos é a</a:t>
+            </a:r>
+          </a:p>
+          <a:p>
+            <a:pPr algn="l"/>
+            <a:r>
+              <a:rPr sz="1400" b="0">
+                <a:solidFill>
+                  <a:srgbClr val="2B2B2B"/>
+                </a:solidFill>
+                <a:latin typeface="Calibri"/>
+              </a:rPr>
+              <a:t>venda que o envio causou:</a:t>
+            </a:r>
+          </a:p>
+          <a:p>
+            <a:pPr algn="l"/>
+            <a:r>
+              <a:rPr sz="1400" b="0">
+                <a:solidFill>
+                  <a:srgbClr val="2B2B2B"/>
+                </a:solidFill>
+                <a:latin typeface="Calibri"/>
+              </a:rPr>
+              <a:t>R$ 9,21 por cliente em 7 dias</a:t>
+            </a:r>
+          </a:p>
+          <a:p>
+            <a:pPr algn="l"/>
+            <a:r>
+              <a:rPr sz="1400" b="0">
+                <a:solidFill>
+                  <a:srgbClr val="2B2B2B"/>
+                </a:solidFill>
+                <a:latin typeface="Calibri"/>
+              </a:rPr>
+              <a:t>(intervalo de confiança 8,45–9,90).</a:t>
+            </a:r>
+          </a:p>
+          <a:p>
+            <a:pPr algn="l"/>
+            <a:r>
+              <a:rPr sz="1400" b="0">
+                <a:solidFill>
+                  <a:srgbClr val="2B2B2B"/>
+                </a:solidFill>
+                <a:latin typeface="Calibri"/>
+              </a:rPr>
+              <a:t/>
+            </a:r>
+          </a:p>
+          <a:p>
+            <a:pPr algn="l"/>
+            <a:r>
+              <a:rPr sz="1400" b="0">
+                <a:solidFill>
+                  <a:srgbClr val="2B2B2B"/>
+                </a:solidFill>
+                <a:latin typeface="Calibri"/>
+              </a:rPr>
+              <a:t>Cupons de desconto rendem mais que</a:t>
+            </a:r>
+          </a:p>
+          <a:p>
+            <a:pPr algn="l"/>
+            <a:r>
+              <a:rPr sz="1400" b="0">
+                <a:solidFill>
+                  <a:srgbClr val="2B2B2B"/>
+                </a:solidFill>
+                <a:latin typeface="Calibri"/>
+              </a:rPr>
+              <a:t>BOGO e que ofertas informativas.</a:t>
+            </a:r>
+          </a:p>
+        </p:txBody>
+      </p:sp>
     </p:spTree>
   </p:cSld>
   <p:clrMapOvr>
@@ -4020,7 +4044,7 @@
                 </a:solidFill>
                 <a:latin typeface="Calibri"/>
               </a:rPr>
-              <a:t>O impacto</a:t>
+              <a:t>A solução</a:t>
             </a:r>
           </a:p>
         </p:txBody>
@@ -4034,7 +4058,7 @@
         <p:spPr>
           <a:xfrm>
             <a:off x="640080" y="777240"/>
-            <a:ext cx="10972800" cy="822960"/>
+            <a:ext cx="11155680" cy="822960"/>
           </a:xfrm>
           <a:prstGeom prst="rect">
             <a:avLst/>
@@ -4049,20 +4073,20 @@
           <a:p>
             <a:pPr algn="l"/>
             <a:r>
-              <a:rPr sz="2800" b="1">
+              <a:rPr sz="2700" b="1">
                 <a:solidFill>
                   <a:srgbClr val="2B2B2B"/>
                 </a:solidFill>
                 <a:latin typeface="Calibri"/>
               </a:rPr>
-              <a:t>Direcionar por uplift entrega mais valor com menos envios</a:t>
+              <a:t>Uma política por cliente: a melhor oferta — ou nenhuma</a:t>
             </a:r>
           </a:p>
         </p:txBody>
       </p:sp>
       <p:pic>
         <p:nvPicPr>
-          <p:cNvPr id="5" name="Picture 4" descr="04_business_impact.png"/>
+          <p:cNvPr id="5" name="Picture 4" descr="08_policy_validation.png"/>
           <p:cNvPicPr>
             <a:picLocks noChangeAspect="1"/>
           </p:cNvPicPr>
@@ -4076,8 +4100,8 @@
         </p:blipFill>
         <p:spPr>
           <a:xfrm>
-            <a:off x="457200" y="1737360"/>
-            <a:ext cx="6583680" cy="3469777"/>
+            <a:off x="548640" y="1828800"/>
+            <a:ext cx="6217920" cy="2973788"/>
           </a:xfrm>
           <a:prstGeom prst="rect">
             <a:avLst/>
@@ -4092,8 +4116,8 @@
         </p:nvSpPr>
         <p:spPr>
           <a:xfrm>
-            <a:off x="7223760" y="1828800"/>
-            <a:ext cx="4572000" cy="548640"/>
+            <a:off x="7040880" y="1828800"/>
+            <a:ext cx="4754880" cy="731520"/>
           </a:xfrm>
           <a:prstGeom prst="rect">
             <a:avLst/>
@@ -4108,13 +4132,13 @@
           <a:p>
             <a:pPr algn="l"/>
             <a:r>
-              <a:rPr sz="1500" b="1">
-                <a:solidFill>
-                  <a:srgbClr val="666666"/>
-                </a:solidFill>
-                <a:latin typeface="Calibri"/>
-              </a:rPr>
-              <a:t>Projeção por 1 milhão de cupons*</a:t>
+              <a:rPr sz="1600" b="1">
+                <a:solidFill>
+                  <a:srgbClr val="2B2B2B"/>
+                </a:solidFill>
+                <a:latin typeface="Calibri"/>
+              </a:rPr>
+              <a:t>O modelo prioriza quem gera valor</a:t>
             </a:r>
           </a:p>
         </p:txBody>
@@ -4127,8 +4151,8 @@
         </p:nvSpPr>
         <p:spPr>
           <a:xfrm>
-            <a:off x="7223760" y="2468880"/>
-            <a:ext cx="4572000" cy="548640"/>
+            <a:off x="7040880" y="2377440"/>
+            <a:ext cx="4846320" cy="2377440"/>
           </a:xfrm>
           <a:prstGeom prst="rect">
             <a:avLst/>
@@ -4143,13 +4167,61 @@
           <a:p>
             <a:pPr algn="l"/>
             <a:r>
-              <a:rPr sz="2600" b="1">
-                <a:solidFill>
-                  <a:srgbClr val="EA1D2C"/>
-                </a:solidFill>
-                <a:latin typeface="Calibri"/>
-              </a:rPr>
-              <a:t>+R$ 1,45M</a:t>
+              <a:rPr sz="1400" b="0">
+                <a:solidFill>
+                  <a:srgbClr val="2B2B2B"/>
+                </a:solidFill>
+                <a:latin typeface="Calibri"/>
+              </a:rPr>
+              <a:t>Testado em campanhas futuras (fora da</a:t>
+            </a:r>
+          </a:p>
+          <a:p>
+            <a:pPr algn="l"/>
+            <a:r>
+              <a:rPr sz="1400" b="0">
+                <a:solidFill>
+                  <a:srgbClr val="2B2B2B"/>
+                </a:solidFill>
+                <a:latin typeface="Calibri"/>
+              </a:rPr>
+              <a:t>amostra de treino): o grupo apontado</a:t>
+            </a:r>
+          </a:p>
+          <a:p>
+            <a:pPr algn="l"/>
+            <a:r>
+              <a:rPr sz="1400" b="0">
+                <a:solidFill>
+                  <a:srgbClr val="2B2B2B"/>
+                </a:solidFill>
+                <a:latin typeface="Calibri"/>
+              </a:rPr>
+              <a:t>como prioritário gerou R$ 21 de venda</a:t>
+            </a:r>
+          </a:p>
+          <a:p>
+            <a:pPr algn="l"/>
+            <a:r>
+              <a:rPr sz="1400" b="0">
+                <a:solidFill>
+                  <a:srgbClr val="2B2B2B"/>
+                </a:solidFill>
+                <a:latin typeface="Calibri"/>
+              </a:rPr>
+              <a:t>incremental por cliente; o grupo de</a:t>
+            </a:r>
+          </a:p>
+          <a:p>
+            <a:pPr algn="l"/>
+            <a:r>
+              <a:rPr sz="1400" b="0">
+                <a:solidFill>
+                  <a:srgbClr val="2B2B2B"/>
+                </a:solidFill>
+                <a:latin typeface="Calibri"/>
+              </a:rPr>
+              <a:t>menor prioridade, zero.</a:t>
             </a:r>
           </a:p>
         </p:txBody>
@@ -4162,8 +4234,8 @@
         </p:nvSpPr>
         <p:spPr>
           <a:xfrm>
-            <a:off x="7223760" y="2971800"/>
-            <a:ext cx="4572000" cy="731520"/>
+            <a:off x="7040880" y="4297680"/>
+            <a:ext cx="4754880" cy="1463040"/>
           </a:xfrm>
           <a:prstGeom prst="rect">
             <a:avLst/>
@@ -4178,224 +4250,25 @@
           <a:p>
             <a:pPr algn="l"/>
             <a:r>
-              <a:rPr sz="1300" b="0">
-                <a:solidFill>
-                  <a:srgbClr val="2B2B2B"/>
-                </a:solidFill>
-                <a:latin typeface="Calibri"/>
-              </a:rPr>
-              <a:t>de valor líquido incremental (+21%)</a:t>
-            </a:r>
-          </a:p>
-          <a:p>
-            <a:pPr algn="l"/>
-            <a:r>
-              <a:rPr sz="1300" b="0">
-                <a:solidFill>
-                  <a:srgbClr val="2B2B2B"/>
-                </a:solidFill>
-                <a:latin typeface="Calibri"/>
-              </a:rPr>
-              <a:t>vs enviar para todos</a:t>
-            </a:r>
-          </a:p>
-        </p:txBody>
-      </p:sp>
-      <p:sp>
-        <p:nvSpPr>
-          <p:cNvPr id="9" name="TextBox 8"/>
-          <p:cNvSpPr txBox="1"/>
-          <p:nvPr/>
-        </p:nvSpPr>
-        <p:spPr>
-          <a:xfrm>
-            <a:off x="7223760" y="3703320"/>
-            <a:ext cx="4572000" cy="548640"/>
-          </a:xfrm>
-          <a:prstGeom prst="rect">
-            <a:avLst/>
-          </a:prstGeom>
-          <a:noFill/>
-        </p:spPr>
-        <p:txBody>
-          <a:bodyPr wrap="square">
-            <a:spAutoFit/>
-          </a:bodyPr>
-          <a:lstStyle/>
-          <a:p>
-            <a:pPr algn="l"/>
-            <a:r>
-              <a:rPr sz="2600" b="1">
+              <a:rPr sz="1900" b="1">
                 <a:solidFill>
                   <a:srgbClr val="EA1D2C"/>
                 </a:solidFill>
                 <a:latin typeface="Calibri"/>
               </a:rPr>
-              <a:t>−20%</a:t>
-            </a:r>
-          </a:p>
-        </p:txBody>
-      </p:sp>
-      <p:sp>
-        <p:nvSpPr>
-          <p:cNvPr id="10" name="TextBox 9"/>
-          <p:cNvSpPr txBox="1"/>
-          <p:nvPr/>
-        </p:nvSpPr>
-        <p:spPr>
-          <a:xfrm>
-            <a:off x="7223760" y="4206240"/>
-            <a:ext cx="4572000" cy="731520"/>
-          </a:xfrm>
-          <a:prstGeom prst="rect">
-            <a:avLst/>
-          </a:prstGeom>
-          <a:noFill/>
-        </p:spPr>
-        <p:txBody>
-          <a:bodyPr wrap="square">
-            <a:spAutoFit/>
-          </a:bodyPr>
-          <a:lstStyle/>
-          <a:p>
-            <a:pPr algn="l"/>
-            <a:r>
-              <a:rPr sz="1300" b="0">
-                <a:solidFill>
-                  <a:srgbClr val="2B2B2B"/>
-                </a:solidFill>
-                <a:latin typeface="Calibri"/>
-              </a:rPr>
-              <a:t>de cupons enviados (menos custo</a:t>
-            </a:r>
-          </a:p>
-          <a:p>
-            <a:pPr algn="l"/>
-            <a:r>
-              <a:rPr sz="1300" b="0">
-                <a:solidFill>
-                  <a:srgbClr val="2B2B2B"/>
-                </a:solidFill>
-                <a:latin typeface="Calibri"/>
-              </a:rPr>
-              <a:t>de mídia e de recompensa)</a:t>
-            </a:r>
-          </a:p>
-        </p:txBody>
-      </p:sp>
-      <p:sp>
-        <p:nvSpPr>
-          <p:cNvPr id="11" name="TextBox 10"/>
-          <p:cNvSpPr txBox="1"/>
-          <p:nvPr/>
-        </p:nvSpPr>
-        <p:spPr>
-          <a:xfrm>
-            <a:off x="7223760" y="4937760"/>
-            <a:ext cx="4572000" cy="548640"/>
-          </a:xfrm>
-          <a:prstGeom prst="rect">
-            <a:avLst/>
-          </a:prstGeom>
-          <a:noFill/>
-        </p:spPr>
-        <p:txBody>
-          <a:bodyPr wrap="square">
-            <a:spAutoFit/>
-          </a:bodyPr>
-          <a:lstStyle/>
-          <a:p>
-            <a:pPr algn="l"/>
-            <a:r>
-              <a:rPr sz="2600" b="1">
+              <a:t>Hoje, só 10% dos clientes</a:t>
+            </a:r>
+          </a:p>
+          <a:p>
+            <a:pPr algn="l"/>
+            <a:r>
+              <a:rPr sz="1900" b="1">
                 <a:solidFill>
                   <a:srgbClr val="EA1D2C"/>
                 </a:solidFill>
                 <a:latin typeface="Calibri"/>
               </a:rPr>
-              <a:t>+13%</a:t>
-            </a:r>
-          </a:p>
-        </p:txBody>
-      </p:sp>
-      <p:sp>
-        <p:nvSpPr>
-          <p:cNvPr id="12" name="TextBox 11"/>
-          <p:cNvSpPr txBox="1"/>
-          <p:nvPr/>
-        </p:nvSpPr>
-        <p:spPr>
-          <a:xfrm>
-            <a:off x="7223760" y="5440680"/>
-            <a:ext cx="4572000" cy="731520"/>
-          </a:xfrm>
-          <a:prstGeom prst="rect">
-            <a:avLst/>
-          </a:prstGeom>
-          <a:noFill/>
-        </p:spPr>
-        <p:txBody>
-          <a:bodyPr wrap="square">
-            <a:spAutoFit/>
-          </a:bodyPr>
-          <a:lstStyle/>
-          <a:p>
-            <a:pPr algn="l"/>
-            <a:r>
-              <a:rPr sz="1300" b="0">
-                <a:solidFill>
-                  <a:srgbClr val="2B2B2B"/>
-                </a:solidFill>
-                <a:latin typeface="Calibri"/>
-              </a:rPr>
-              <a:t>mais conclusões incrementais,</a:t>
-            </a:r>
-          </a:p>
-          <a:p>
-            <a:pPr algn="l"/>
-            <a:r>
-              <a:rPr sz="1300" b="0">
-                <a:solidFill>
-                  <a:srgbClr val="2B2B2B"/>
-                </a:solidFill>
-                <a:latin typeface="Calibri"/>
-              </a:rPr>
-              <a:t>ao cortar quem tem uplift negativo</a:t>
-            </a:r>
-          </a:p>
-        </p:txBody>
-      </p:sp>
-      <p:sp>
-        <p:nvSpPr>
-          <p:cNvPr id="13" name="TextBox 12"/>
-          <p:cNvSpPr txBox="1"/>
-          <p:nvPr/>
-        </p:nvSpPr>
-        <p:spPr>
-          <a:xfrm>
-            <a:off x="548640" y="6355080"/>
-            <a:ext cx="10972800" cy="365760"/>
-          </a:xfrm>
-          <a:prstGeom prst="rect">
-            <a:avLst/>
-          </a:prstGeom>
-          <a:noFill/>
-        </p:spPr>
-        <p:txBody>
-          <a:bodyPr wrap="square">
-            <a:spAutoFit/>
-          </a:bodyPr>
-          <a:lstStyle/>
-          <a:p>
-            <a:pPr algn="l"/>
-            <a:r>
-              <a:rPr sz="1000" b="0">
-                <a:solidFill>
-                  <a:srgbClr val="666666"/>
-                </a:solidFill>
-                <a:latin typeface="Calibri"/>
-              </a:rPr>
-              <a:t>*Escala das taxas observadas em holdout; ticket médio/conclusão R$52,60, recompensa média R$4,90.</a:t>
+              <a:t>recebem a sua melhor oferta.</a:t>
             </a:r>
           </a:p>
         </p:txBody>
@@ -4491,7 +4364,7 @@
                 </a:solidFill>
                 <a:latin typeface="Calibri"/>
               </a:rPr>
-              <a:t>Como funciona e próximos passos</a:t>
+              <a:t>Impacto e próximos passos</a:t>
             </a:r>
           </a:p>
         </p:txBody>
@@ -4505,7 +4378,7 @@
         <p:spPr>
           <a:xfrm>
             <a:off x="640080" y="777240"/>
-            <a:ext cx="10972800" cy="822960"/>
+            <a:ext cx="11155680" cy="822960"/>
           </a:xfrm>
           <a:prstGeom prst="rect">
             <a:avLst/>
@@ -4520,27 +4393,51 @@
           <a:p>
             <a:pPr algn="l"/>
             <a:r>
-              <a:rPr sz="2800" b="1">
+              <a:rPr sz="2700" b="1">
                 <a:solidFill>
                   <a:srgbClr val="2B2B2B"/>
                 </a:solidFill>
                 <a:latin typeface="Calibri"/>
               </a:rPr>
-              <a:t>Pronto para um piloto controlado</a:t>
-            </a:r>
-          </a:p>
-        </p:txBody>
-      </p:sp>
-      <p:sp>
-        <p:nvSpPr>
-          <p:cNvPr id="5" name="TextBox 4"/>
+              <a:t>De R$ 10,3M para R$ 12,3M por milhão de envios — com upside a testar</a:t>
+            </a:r>
+          </a:p>
+        </p:txBody>
+      </p:sp>
+      <p:pic>
+        <p:nvPicPr>
+          <p:cNvPr id="5" name="Picture 4" descr="09_business_impact.png"/>
+          <p:cNvPicPr>
+            <a:picLocks noChangeAspect="1"/>
+          </p:cNvPicPr>
+          <p:nvPr/>
+        </p:nvPicPr>
+        <p:blipFill>
+          <a:blip r:embed="rId2"/>
+          <a:stretch>
+            <a:fillRect/>
+          </a:stretch>
+        </p:blipFill>
+        <p:spPr>
+          <a:xfrm>
+            <a:off x="457200" y="1828800"/>
+            <a:ext cx="6309360" cy="2984157"/>
+          </a:xfrm>
+          <a:prstGeom prst="rect">
+            <a:avLst/>
+          </a:prstGeom>
+        </p:spPr>
+      </p:pic>
+      <p:sp>
+        <p:nvSpPr>
+          <p:cNvPr id="6" name="TextBox 5"/>
           <p:cNvSpPr txBox="1"/>
           <p:nvPr/>
         </p:nvSpPr>
         <p:spPr>
           <a:xfrm>
-            <a:off x="640080" y="1737360"/>
-            <a:ext cx="5486400" cy="4114800"/>
+            <a:off x="7040880" y="1828800"/>
+            <a:ext cx="4846320" cy="1737360"/>
           </a:xfrm>
           <a:prstGeom prst="rect">
             <a:avLst/>
@@ -4555,39 +4452,87 @@
           <a:p>
             <a:pPr algn="l"/>
             <a:r>
-              <a:rPr sz="1800" b="1">
+              <a:rPr sz="1400" b="0">
                 <a:solidFill>
                   <a:srgbClr val="2B2B2B"/>
                 </a:solidFill>
                 <a:latin typeface="Calibri"/>
               </a:rPr>
-              <a:t>Como funciona</a:t>
-            </a:r>
-          </a:p>
-          <a:p>
-            <a:pPr algn="l"/>
-            <a:r>
-              <a:rPr sz="1800" b="1">
+              <a:t>+R$ 2,0M (+20%) por 1M de envios já</a:t>
+            </a:r>
+          </a:p>
+          <a:p>
+            <a:pPr algn="l"/>
+            <a:r>
+              <a:rPr sz="1400" b="0">
                 <a:solidFill>
                   <a:srgbClr val="2B2B2B"/>
                 </a:solidFill>
                 <a:latin typeface="Calibri"/>
               </a:rPr>
-              <a:t/>
-            </a:r>
-          </a:p>
-        </p:txBody>
-      </p:sp>
-      <p:sp>
-        <p:nvSpPr>
-          <p:cNvPr id="6" name="TextBox 5"/>
+              <a:t>no cenário conservador, enviando 5%</a:t>
+            </a:r>
+          </a:p>
+          <a:p>
+            <a:pPr algn="l"/>
+            <a:r>
+              <a:rPr sz="1400" b="0">
+                <a:solidFill>
+                  <a:srgbClr val="2B2B2B"/>
+                </a:solidFill>
+                <a:latin typeface="Calibri"/>
+              </a:rPr>
+              <a:t>menos cupons.</a:t>
+            </a:r>
+          </a:p>
+          <a:p>
+            <a:pPr algn="l"/>
+            <a:r>
+              <a:rPr sz="1400" b="0">
+                <a:solidFill>
+                  <a:srgbClr val="2B2B2B"/>
+                </a:solidFill>
+                <a:latin typeface="Calibri"/>
+              </a:rPr>
+              <a:t>Potencial de ~R$ 29M com persona-</a:t>
+            </a:r>
+          </a:p>
+          <a:p>
+            <a:pPr algn="l"/>
+            <a:r>
+              <a:rPr sz="1400" b="0">
+                <a:solidFill>
+                  <a:srgbClr val="2B2B2B"/>
+                </a:solidFill>
+                <a:latin typeface="Calibri"/>
+              </a:rPr>
+              <a:t>lização total — número de modelo, a</a:t>
+            </a:r>
+          </a:p>
+          <a:p>
+            <a:pPr algn="l"/>
+            <a:r>
+              <a:rPr sz="1400" b="0">
+                <a:solidFill>
+                  <a:srgbClr val="2B2B2B"/>
+                </a:solidFill>
+                <a:latin typeface="Calibri"/>
+              </a:rPr>
+              <a:t>confirmar em teste controlado.</a:t>
+            </a:r>
+          </a:p>
+        </p:txBody>
+      </p:sp>
+      <p:sp>
+        <p:nvSpPr>
+          <p:cNvPr id="7" name="TextBox 6"/>
           <p:cNvSpPr txBox="1"/>
           <p:nvPr/>
         </p:nvSpPr>
         <p:spPr>
           <a:xfrm>
-            <a:off x="640080" y="2377440"/>
-            <a:ext cx="5577840" cy="4114800"/>
+            <a:off x="7040880" y="3749039"/>
+            <a:ext cx="4754880" cy="548640"/>
           </a:xfrm>
           <a:prstGeom prst="rect">
             <a:avLst/>
@@ -4602,147 +4547,27 @@
           <a:p>
             <a:pPr algn="l"/>
             <a:r>
-              <a:rPr sz="1500" b="0">
+              <a:rPr sz="1600" b="1">
                 <a:solidFill>
                   <a:srgbClr val="2B2B2B"/>
                 </a:solidFill>
                 <a:latin typeface="Calibri"/>
               </a:rPr>
-              <a:t>1.  Modelo de uplift (T-learner/XGBoost)</a:t>
-            </a:r>
-          </a:p>
-          <a:p>
-            <a:pPr algn="l"/>
-            <a:r>
-              <a:rPr sz="1500" b="0">
-                <a:solidFill>
-                  <a:srgbClr val="2B2B2B"/>
-                </a:solidFill>
-                <a:latin typeface="Calibri"/>
-              </a:rPr>
-              <a:t>     pontua cada cliente × oferta.</a:t>
-            </a:r>
-          </a:p>
-          <a:p>
-            <a:pPr algn="l"/>
-            <a:r>
-              <a:rPr sz="1500" b="0">
-                <a:solidFill>
-                  <a:srgbClr val="2B2B2B"/>
-                </a:solidFill>
-                <a:latin typeface="Calibri"/>
-              </a:rPr>
-              <a:t/>
-            </a:r>
-          </a:p>
-          <a:p>
-            <a:pPr algn="l"/>
-            <a:r>
-              <a:rPr sz="1500" b="0">
-                <a:solidFill>
-                  <a:srgbClr val="2B2B2B"/>
-                </a:solidFill>
-                <a:latin typeface="Calibri"/>
-              </a:rPr>
-              <a:t>2.  Para cada cliente, recomenda a oferta</a:t>
-            </a:r>
-          </a:p>
-          <a:p>
-            <a:pPr algn="l"/>
-            <a:r>
-              <a:rPr sz="1500" b="0">
-                <a:solidFill>
-                  <a:srgbClr val="2B2B2B"/>
-                </a:solidFill>
-                <a:latin typeface="Calibri"/>
-              </a:rPr>
-              <a:t>     de maior uplift — ou nenhuma.</a:t>
-            </a:r>
-          </a:p>
-          <a:p>
-            <a:pPr algn="l"/>
-            <a:r>
-              <a:rPr sz="1500" b="0">
-                <a:solidFill>
-                  <a:srgbClr val="2B2B2B"/>
-                </a:solidFill>
-                <a:latin typeface="Calibri"/>
-              </a:rPr>
-              <a:t/>
-            </a:r>
-          </a:p>
-          <a:p>
-            <a:pPr algn="l"/>
-            <a:r>
-              <a:rPr sz="1500" b="0">
-                <a:solidFill>
-                  <a:srgbClr val="2B2B2B"/>
-                </a:solidFill>
-                <a:latin typeface="Calibri"/>
-              </a:rPr>
-              <a:t>3.  Só envia a quem tem retorno incremental</a:t>
-            </a:r>
-          </a:p>
-          <a:p>
-            <a:pPr algn="l"/>
-            <a:r>
-              <a:rPr sz="1500" b="0">
-                <a:solidFill>
-                  <a:srgbClr val="2B2B2B"/>
-                </a:solidFill>
-                <a:latin typeface="Calibri"/>
-              </a:rPr>
-              <a:t>     positivo (≈10% da base não deve receber).</a:t>
-            </a:r>
-          </a:p>
-          <a:p>
-            <a:pPr algn="l"/>
-            <a:r>
-              <a:rPr sz="1500" b="0">
-                <a:solidFill>
-                  <a:srgbClr val="2B2B2B"/>
-                </a:solidFill>
-                <a:latin typeface="Calibri"/>
-              </a:rPr>
-              <a:t/>
-            </a:r>
-          </a:p>
-          <a:p>
-            <a:pPr algn="l"/>
-            <a:r>
-              <a:rPr sz="1500" b="0">
-                <a:solidFill>
-                  <a:srgbClr val="2B2B2B"/>
-                </a:solidFill>
-                <a:latin typeface="Calibri"/>
-              </a:rPr>
-              <a:t>Qualidade do modelo: ranqueia o uplift</a:t>
-            </a:r>
-          </a:p>
-          <a:p>
-            <a:pPr algn="l"/>
-            <a:r>
-              <a:rPr sz="1500" b="0">
-                <a:solidFill>
-                  <a:srgbClr val="2B2B2B"/>
-                </a:solidFill>
-                <a:latin typeface="Calibri"/>
-              </a:rPr>
-              <a:t>~2x melhor que a abordagem padrão (Qini).</a:t>
-            </a:r>
-          </a:p>
-        </p:txBody>
-      </p:sp>
-      <p:sp>
-        <p:nvSpPr>
-          <p:cNvPr id="7" name="TextBox 6"/>
+              <a:t>Próximos passos</a:t>
+            </a:r>
+          </a:p>
+        </p:txBody>
+      </p:sp>
+      <p:sp>
+        <p:nvSpPr>
+          <p:cNvPr id="8" name="TextBox 7"/>
           <p:cNvSpPr txBox="1"/>
           <p:nvPr/>
         </p:nvSpPr>
         <p:spPr>
           <a:xfrm>
-            <a:off x="6583680" y="1737360"/>
-            <a:ext cx="5120640" cy="640080"/>
+            <a:off x="7040880" y="4297680"/>
+            <a:ext cx="4846320" cy="2011680"/>
           </a:xfrm>
           <a:prstGeom prst="rect">
             <a:avLst/>
@@ -4757,156 +4582,61 @@
           <a:p>
             <a:pPr algn="l"/>
             <a:r>
-              <a:rPr sz="1800" b="1">
+              <a:rPr sz="1400" b="0">
                 <a:solidFill>
                   <a:srgbClr val="2B2B2B"/>
                 </a:solidFill>
                 <a:latin typeface="Calibri"/>
               </a:rPr>
-              <a:t>Próximos passos</a:t>
-            </a:r>
-          </a:p>
-        </p:txBody>
-      </p:sp>
-      <p:sp>
-        <p:nvSpPr>
-          <p:cNvPr id="8" name="TextBox 7"/>
-          <p:cNvSpPr txBox="1"/>
-          <p:nvPr/>
-        </p:nvSpPr>
-        <p:spPr>
-          <a:xfrm>
-            <a:off x="6583680" y="2377440"/>
-            <a:ext cx="5212080" cy="4114800"/>
-          </a:xfrm>
-          <a:prstGeom prst="rect">
-            <a:avLst/>
-          </a:prstGeom>
-          <a:noFill/>
-        </p:spPr>
-        <p:txBody>
-          <a:bodyPr wrap="square">
-            <a:spAutoFit/>
-          </a:bodyPr>
-          <a:lstStyle/>
-          <a:p>
-            <a:pPr algn="l"/>
-            <a:r>
-              <a:rPr sz="1500" b="0">
+              <a:t>1. Teste A/B com grupo de controle</a:t>
+            </a:r>
+          </a:p>
+          <a:p>
+            <a:pPr algn="l"/>
+            <a:r>
+              <a:rPr sz="1400" b="0">
                 <a:solidFill>
                   <a:srgbClr val="2B2B2B"/>
                 </a:solidFill>
                 <a:latin typeface="Calibri"/>
               </a:rPr>
-              <a:t>•  A/B test com grupo de controle real</a:t>
-            </a:r>
-          </a:p>
-          <a:p>
-            <a:pPr algn="l"/>
-            <a:r>
-              <a:rPr sz="1500" b="0">
+              <a:t>    para confirmar os ganhos</a:t>
+            </a:r>
+          </a:p>
+          <a:p>
+            <a:pPr algn="l"/>
+            <a:r>
+              <a:rPr sz="1400" b="0">
                 <a:solidFill>
                   <a:srgbClr val="2B2B2B"/>
                 </a:solidFill>
                 <a:latin typeface="Calibri"/>
               </a:rPr>
-              <a:t>   (holdout sem oferta) para validar o uplift.</a:t>
-            </a:r>
-          </a:p>
-          <a:p>
-            <a:pPr algn="l"/>
-            <a:r>
-              <a:rPr sz="1500" b="0">
+              <a:t>2. Alocação sob orçamento de cupons</a:t>
+            </a:r>
+          </a:p>
+          <a:p>
+            <a:pPr algn="l"/>
+            <a:r>
+              <a:rPr sz="1400" b="0">
                 <a:solidFill>
                   <a:srgbClr val="2B2B2B"/>
                 </a:solidFill>
                 <a:latin typeface="Calibri"/>
               </a:rPr>
-              <a:t/>
-            </a:r>
-          </a:p>
-          <a:p>
-            <a:pPr algn="l"/>
-            <a:r>
-              <a:rPr sz="1500" b="0">
+              <a:t>3. Otimização de timing e canal</a:t>
+            </a:r>
+          </a:p>
+          <a:p>
+            <a:pPr algn="l"/>
+            <a:r>
+              <a:rPr sz="1400" b="0">
                 <a:solidFill>
                   <a:srgbClr val="2B2B2B"/>
                 </a:solidFill>
                 <a:latin typeface="Calibri"/>
               </a:rPr>
-              <a:t>•  Otimização de timing e canal do envio.</a:t>
-            </a:r>
-          </a:p>
-          <a:p>
-            <a:pPr algn="l"/>
-            <a:r>
-              <a:rPr sz="1500" b="0">
-                <a:solidFill>
-                  <a:srgbClr val="2B2B2B"/>
-                </a:solidFill>
-                <a:latin typeface="Calibri"/>
-              </a:rPr>
-              <a:t/>
-            </a:r>
-          </a:p>
-          <a:p>
-            <a:pPr algn="l"/>
-            <a:r>
-              <a:rPr sz="1500" b="0">
-                <a:solidFill>
-                  <a:srgbClr val="2B2B2B"/>
-                </a:solidFill>
-                <a:latin typeface="Calibri"/>
-              </a:rPr>
-              <a:t>•  Alocação sob orçamento (uplift por R$</a:t>
-            </a:r>
-          </a:p>
-          <a:p>
-            <a:pPr algn="l"/>
-            <a:r>
-              <a:rPr sz="1500" b="0">
-                <a:solidFill>
-                  <a:srgbClr val="2B2B2B"/>
-                </a:solidFill>
-                <a:latin typeface="Calibri"/>
-              </a:rPr>
-              <a:t>   investido).</a:t>
-            </a:r>
-          </a:p>
-          <a:p>
-            <a:pPr algn="l"/>
-            <a:r>
-              <a:rPr sz="1500" b="0">
-                <a:solidFill>
-                  <a:srgbClr val="2B2B2B"/>
-                </a:solidFill>
-                <a:latin typeface="Calibri"/>
-              </a:rPr>
-              <a:t/>
-            </a:r>
-          </a:p>
-          <a:p>
-            <a:pPr algn="l"/>
-            <a:r>
-              <a:rPr sz="1500" b="0">
-                <a:solidFill>
-                  <a:srgbClr val="2B2B2B"/>
-                </a:solidFill>
-                <a:latin typeface="Calibri"/>
-              </a:rPr>
-              <a:t>•  Colocar o score em produção no motor</a:t>
-            </a:r>
-          </a:p>
-          <a:p>
-            <a:pPr algn="l"/>
-            <a:r>
-              <a:rPr sz="1500" b="0">
-                <a:solidFill>
-                  <a:srgbClr val="2B2B2B"/>
-                </a:solidFill>
-                <a:latin typeface="Calibri"/>
-              </a:rPr>
-              <a:t>   de campanhas de CRM.</a:t>
+              <a:t>4. Integração ao motor de campanhas</a:t>
             </a:r>
           </a:p>
         </p:txBody>

</xml_diff>

<commit_message>
Refaz o deck com narrativa atualizada e slide de conclusao
- Tese na capa: "o problema nao e quanto se gasta em cupom, e para quem
  se manda" -- resume o achado central em uma frase
- Slide 5 vira A CONCLUSAO, com os 3 aprendizados do experimento:
  1. cupom funciona, mas o efeito vai de R$21 a zero conforme a pessoa
  2. medir "quem usou o cupom" engana (quem gasta muito usa de qualquer
     jeito) -- so a comparacao com quem nao recebeu revela o efeito real
  3. o dinheiro esta em acertar o alvo, nao em cortar envios
- Graficos: funil com ordem, efeito por tipo de oferta, validacao por
  faixas e impacto financeiro
- Linguagem alinhada a simplificacao dos notebooks

Co-Authored-By: Claude Fable 5 <noreply@anthropic.com>
</commit_message>
<xml_diff>
--- a/presentation/ifood_case.pptx
+++ b/presentation/ifood_case.pptx
@@ -3143,8 +3143,8 @@
         </p:nvSpPr>
         <p:spPr>
           <a:xfrm>
-            <a:off x="822960" y="2011680"/>
-            <a:ext cx="10515600" cy="914400"/>
+            <a:off x="822960" y="1828800"/>
+            <a:ext cx="10515600" cy="457200"/>
           </a:xfrm>
           <a:prstGeom prst="rect">
             <a:avLst/>
@@ -3178,8 +3178,8 @@
         </p:nvSpPr>
         <p:spPr>
           <a:xfrm>
-            <a:off x="822960" y="2651760"/>
-            <a:ext cx="10789920" cy="1463040"/>
+            <a:off x="822960" y="2468880"/>
+            <a:ext cx="10789920" cy="1645920"/>
           </a:xfrm>
           <a:prstGeom prst="rect">
             <a:avLst/>
@@ -3200,7 +3200,7 @@
                 </a:solidFill>
                 <a:latin typeface="Calibri"/>
               </a:rPr>
-              <a:t>A oferta certa, para o cliente certo —</a:t>
+              <a:t>O problema não é quanto se gasta em cupom.</a:t>
             </a:r>
           </a:p>
           <a:p>
@@ -3212,7 +3212,7 @@
                 </a:solidFill>
                 <a:latin typeface="Calibri"/>
               </a:rPr>
-              <a:t>e só quando ela gera venda nova</a:t>
+              <a:t>É para quem se manda.</a:t>
             </a:r>
           </a:p>
         </p:txBody>
@@ -3225,7 +3225,7 @@
         </p:nvSpPr>
         <p:spPr>
           <a:xfrm>
-            <a:off x="822960" y="4480560"/>
+            <a:off x="822960" y="4389120"/>
             <a:ext cx="10515600" cy="1097280"/>
           </a:xfrm>
           <a:prstGeom prst="rect">
@@ -3247,7 +3247,7 @@
                 </a:solidFill>
                 <a:latin typeface="Calibri"/>
               </a:rPr>
-              <a:t>Medimos o efeito real de cada envio (venda incremental, descontado o cupom)</a:t>
+              <a:t>Medimos o quanto cada envio realmente gera de venda nova — e descobrimos que</a:t>
             </a:r>
           </a:p>
           <a:p>
@@ -3259,7 +3259,7 @@
                 </a:solidFill>
                 <a:latin typeface="Calibri"/>
               </a:rPr>
-              <a:t>e transformamos isso numa política de envio por cliente.</a:t>
+              <a:t>9 em cada 10 clientes recebem a oferta errada.</a:t>
             </a:r>
           </a:p>
         </p:txBody>
@@ -3294,7 +3294,7 @@
                 </a:solidFill>
                 <a:latin typeface="Calibri"/>
               </a:rPr>
-              <a:t>Base: 17 mil clientes · 306 mil eventos · 76 mil envios em 6 campanhas</a:t>
+              <a:t>17 mil clientes · 306 mil eventos · 76 mil envios em 6 campanhas · 30 dias</a:t>
             </a:r>
           </a:p>
         </p:txBody>
@@ -3419,13 +3419,13 @@
           <a:p>
             <a:pPr algn="l"/>
             <a:r>
-              <a:rPr sz="2700" b="1">
+              <a:rPr sz="2600" b="1">
                 <a:solidFill>
                   <a:srgbClr val="2B2B2B"/>
                 </a:solidFill>
                 <a:latin typeface="Calibri"/>
               </a:rPr>
-              <a:t>Parte do orçamento de cupons não gera venda nova</a:t>
+              <a:t>Quase um terço do desconto sai do caixa sem gerar nada</a:t>
             </a:r>
           </a:p>
         </p:txBody>
@@ -3446,7 +3446,7 @@
         </p:blipFill>
         <p:spPr>
           <a:xfrm>
-            <a:off x="548640" y="1828800"/>
+            <a:off x="548640" y="1737360"/>
             <a:ext cx="6583680" cy="2874565"/>
           </a:xfrm>
           <a:prstGeom prst="rect">
@@ -3462,8 +3462,8 @@
         </p:nvSpPr>
         <p:spPr>
           <a:xfrm>
-            <a:off x="7406640" y="1920240"/>
-            <a:ext cx="4389120" cy="822960"/>
+            <a:off x="7406640" y="1828800"/>
+            <a:ext cx="4389120" cy="914400"/>
           </a:xfrm>
           <a:prstGeom prst="rect">
             <a:avLst/>
@@ -3478,25 +3478,37 @@
           <a:p>
             <a:pPr algn="l"/>
             <a:r>
-              <a:rPr sz="2100" b="1">
+              <a:rPr sz="2000" b="1">
                 <a:solidFill>
                   <a:srgbClr val="EA1D2C"/>
                 </a:solidFill>
                 <a:latin typeface="Calibri"/>
               </a:rPr>
-              <a:t>~30% dos cupons pagos</a:t>
-            </a:r>
-          </a:p>
-          <a:p>
-            <a:pPr algn="l"/>
-            <a:r>
-              <a:rPr sz="2100" b="1">
+              <a:t>30% dos cupons são usados</a:t>
+            </a:r>
+          </a:p>
+          <a:p>
+            <a:pPr algn="l"/>
+            <a:r>
+              <a:rPr sz="2000" b="1">
                 <a:solidFill>
                   <a:srgbClr val="EA1D2C"/>
                 </a:solidFill>
                 <a:latin typeface="Calibri"/>
               </a:rPr>
-              <a:t>não influenciaram a compra</a:t>
+              <a:t>sem o cliente ter visto</a:t>
+            </a:r>
+          </a:p>
+          <a:p>
+            <a:pPr algn="l"/>
+            <a:r>
+              <a:rPr sz="2000" b="1">
+                <a:solidFill>
+                  <a:srgbClr val="EA1D2C"/>
+                </a:solidFill>
+                <a:latin typeface="Calibri"/>
+              </a:rPr>
+              <a:t>a oferta antes</a:t>
             </a:r>
           </a:p>
         </p:txBody>
@@ -3509,7 +3521,7 @@
         </p:nvSpPr>
         <p:spPr>
           <a:xfrm>
-            <a:off x="7406640" y="3200400"/>
+            <a:off x="7406640" y="3291840"/>
             <a:ext cx="4480560" cy="2926080"/>
           </a:xfrm>
           <a:prstGeom prst="rect">
@@ -3531,7 +3543,7 @@
                 </a:solidFill>
                 <a:latin typeface="Calibri"/>
               </a:rPr>
-              <a:t>O cliente atingiu o valor mínimo e o</a:t>
+              <a:t>O cliente faz uma compra normal,</a:t>
             </a:r>
           </a:p>
           <a:p>
@@ -3543,7 +3555,7 @@
                 </a:solidFill>
                 <a:latin typeface="Calibri"/>
               </a:rPr>
-              <a:t>cupom foi resgatado sem que ele</a:t>
+              <a:t>atinge o valor mínimo sem saber</a:t>
             </a:r>
           </a:p>
           <a:p>
@@ -3555,7 +3567,7 @@
                 </a:solidFill>
                 <a:latin typeface="Calibri"/>
               </a:rPr>
-              <a:t>tivesse visto a oferta — a compra</a:t>
+              <a:t>que havia uma oferta — e o sistema</a:t>
             </a:r>
           </a:p>
           <a:p>
@@ -3567,7 +3579,7 @@
                 </a:solidFill>
                 <a:latin typeface="Calibri"/>
               </a:rPr>
-              <a:t>aconteceria de qualquer forma.</a:t>
+              <a:t>desconta automaticamente.</a:t>
             </a:r>
           </a:p>
           <a:p>
@@ -3591,7 +3603,7 @@
                 </a:solidFill>
                 <a:latin typeface="Calibri"/>
               </a:rPr>
-              <a:t>Enviar a mesma oferta para todos</a:t>
+              <a:t>É uma venda que aconteceria de</a:t>
             </a:r>
           </a:p>
           <a:p>
@@ -3603,7 +3615,31 @@
                 </a:solidFill>
                 <a:latin typeface="Calibri"/>
               </a:rPr>
-              <a:t>ignora quem responde e quem não.</a:t>
+              <a:t>qualquer forma, só que mais barata</a:t>
+            </a:r>
+          </a:p>
+          <a:p>
+            <a:pPr algn="l"/>
+            <a:r>
+              <a:rPr sz="1500" b="0">
+                <a:solidFill>
+                  <a:srgbClr val="2B2B2B"/>
+                </a:solidFill>
+                <a:latin typeface="Calibri"/>
+              </a:rPr>
+              <a:t>para o cliente e mais cara</a:t>
+            </a:r>
+          </a:p>
+          <a:p>
+            <a:pPr algn="l"/>
+            <a:r>
+              <a:rPr sz="1500" b="0">
+                <a:solidFill>
+                  <a:srgbClr val="2B2B2B"/>
+                </a:solidFill>
+                <a:latin typeface="Calibri"/>
+              </a:rPr>
+              <a:t>para a empresa.</a:t>
             </a:r>
           </a:p>
         </p:txBody>
@@ -3699,7 +3735,7 @@
                 </a:solidFill>
                 <a:latin typeface="Calibri"/>
               </a:rPr>
-              <a:t>Quanto vale um envio</a:t>
+              <a:t>O que descobrimos</a:t>
             </a:r>
           </a:p>
         </p:txBody>
@@ -3728,13 +3764,13 @@
           <a:p>
             <a:pPr algn="l"/>
             <a:r>
-              <a:rPr sz="2700" b="1">
+              <a:rPr sz="2600" b="1">
                 <a:solidFill>
                   <a:srgbClr val="2B2B2B"/>
                 </a:solidFill>
                 <a:latin typeface="Calibri"/>
               </a:rPr>
-              <a:t>Cada envio gera, em média, R$ 9 de venda nova — já descontado o cupom</a:t>
+              <a:t>Enviar compensa — mas o efeito depende muito da oferta</a:t>
             </a:r>
           </a:p>
         </p:txBody>
@@ -3771,8 +3807,8 @@
         </p:nvSpPr>
         <p:spPr>
           <a:xfrm>
-            <a:off x="7040880" y="1920240"/>
-            <a:ext cx="4754880" cy="731520"/>
+            <a:off x="7040880" y="1828800"/>
+            <a:ext cx="4846320" cy="640080"/>
           </a:xfrm>
           <a:prstGeom prst="rect">
             <a:avLst/>
@@ -3806,8 +3842,8 @@
         </p:nvSpPr>
         <p:spPr>
           <a:xfrm>
-            <a:off x="7040880" y="2468880"/>
-            <a:ext cx="4846320" cy="3291840"/>
+            <a:off x="7040880" y="2377440"/>
+            <a:ext cx="4846320" cy="2377440"/>
           </a:xfrm>
           <a:prstGeom prst="rect">
             <a:avLst/>
@@ -3822,13 +3858,155 @@
           <a:p>
             <a:pPr algn="l"/>
             <a:r>
+              <a:rPr sz="1500" b="0">
+                <a:solidFill>
+                  <a:srgbClr val="2B2B2B"/>
+                </a:solidFill>
+                <a:latin typeface="Calibri"/>
+              </a:rPr>
+              <a:t>Em cada campanha, 25% dos clientes</a:t>
+            </a:r>
+          </a:p>
+          <a:p>
+            <a:pPr algn="l"/>
+            <a:r>
+              <a:rPr sz="1500" b="0">
+                <a:solidFill>
+                  <a:srgbClr val="2B2B2B"/>
+                </a:solidFill>
+                <a:latin typeface="Calibri"/>
+              </a:rPr>
+              <a:t>não receberam nada. Esse grupo mostra</a:t>
+            </a:r>
+          </a:p>
+          <a:p>
+            <a:pPr algn="l"/>
+            <a:r>
+              <a:rPr sz="1500" b="0">
+                <a:solidFill>
+                  <a:srgbClr val="2B2B2B"/>
+                </a:solidFill>
+                <a:latin typeface="Calibri"/>
+              </a:rPr>
+              <a:t>o que teria acontecido sem o envio.</a:t>
+            </a:r>
+          </a:p>
+          <a:p>
+            <a:pPr algn="l"/>
+            <a:r>
+              <a:rPr sz="1500" b="0">
+                <a:solidFill>
+                  <a:srgbClr val="2B2B2B"/>
+                </a:solidFill>
+                <a:latin typeface="Calibri"/>
+              </a:rPr>
+              <a:t/>
+            </a:r>
+          </a:p>
+          <a:p>
+            <a:pPr algn="l"/>
+            <a:r>
+              <a:rPr sz="1500" b="0">
+                <a:solidFill>
+                  <a:srgbClr val="2B2B2B"/>
+                </a:solidFill>
+                <a:latin typeface="Calibri"/>
+              </a:rPr>
+              <a:t>A diferença entre os dois grupos é a</a:t>
+            </a:r>
+          </a:p>
+          <a:p>
+            <a:pPr algn="l"/>
+            <a:r>
+              <a:rPr sz="1500" b="0">
+                <a:solidFill>
+                  <a:srgbClr val="2B2B2B"/>
+                </a:solidFill>
+                <a:latin typeface="Calibri"/>
+              </a:rPr>
+              <a:t>venda que o envio causou.</a:t>
+            </a:r>
+          </a:p>
+        </p:txBody>
+      </p:sp>
+      <p:sp>
+        <p:nvSpPr>
+          <p:cNvPr id="8" name="TextBox 7"/>
+          <p:cNvSpPr txBox="1"/>
+          <p:nvPr/>
+        </p:nvSpPr>
+        <p:spPr>
+          <a:xfrm>
+            <a:off x="7040880" y="4389120"/>
+            <a:ext cx="4846320" cy="822960"/>
+          </a:xfrm>
+          <a:prstGeom prst="rect">
+            <a:avLst/>
+          </a:prstGeom>
+          <a:noFill/>
+        </p:spPr>
+        <p:txBody>
+          <a:bodyPr wrap="square">
+            <a:spAutoFit/>
+          </a:bodyPr>
+          <a:lstStyle/>
+          <a:p>
+            <a:pPr algn="l"/>
+            <a:r>
+              <a:rPr sz="2200" b="1">
+                <a:solidFill>
+                  <a:srgbClr val="2E7D32"/>
+                </a:solidFill>
+                <a:latin typeface="Calibri"/>
+              </a:rPr>
+              <a:t>R$ 9,21 de venda nova</a:t>
+            </a:r>
+          </a:p>
+          <a:p>
+            <a:pPr algn="l"/>
+            <a:r>
+              <a:rPr sz="2200" b="1">
+                <a:solidFill>
+                  <a:srgbClr val="2E7D32"/>
+                </a:solidFill>
+                <a:latin typeface="Calibri"/>
+              </a:rPr>
+              <a:t>por cliente, em 7 dias</a:t>
+            </a:r>
+          </a:p>
+        </p:txBody>
+      </p:sp>
+      <p:sp>
+        <p:nvSpPr>
+          <p:cNvPr id="9" name="TextBox 8"/>
+          <p:cNvSpPr txBox="1"/>
+          <p:nvPr/>
+        </p:nvSpPr>
+        <p:spPr>
+          <a:xfrm>
+            <a:off x="7040880" y="5486400"/>
+            <a:ext cx="4846320" cy="731520"/>
+          </a:xfrm>
+          <a:prstGeom prst="rect">
+            <a:avLst/>
+          </a:prstGeom>
+          <a:noFill/>
+        </p:spPr>
+        <p:txBody>
+          <a:bodyPr wrap="square">
+            <a:spAutoFit/>
+          </a:bodyPr>
+          <a:lstStyle/>
+          <a:p>
+            <a:pPr algn="l"/>
+            <a:r>
               <a:rPr sz="1400" b="0">
                 <a:solidFill>
                   <a:srgbClr val="2B2B2B"/>
                 </a:solidFill>
                 <a:latin typeface="Calibri"/>
               </a:rPr>
-              <a:t>Em cada campanha, ~25% dos clientes</a:t>
+              <a:t>Já descontado o custo do cupom.</a:t>
             </a:r>
           </a:p>
           <a:p>
@@ -3840,115 +4018,7 @@
                 </a:solidFill>
                 <a:latin typeface="Calibri"/>
               </a:rPr>
-              <a:t>não receberam oferta — um grupo de</a:t>
-            </a:r>
-          </a:p>
-          <a:p>
-            <a:pPr algn="l"/>
-            <a:r>
-              <a:rPr sz="1400" b="0">
-                <a:solidFill>
-                  <a:srgbClr val="2B2B2B"/>
-                </a:solidFill>
-                <a:latin typeface="Calibri"/>
-              </a:rPr>
-              <a:t>comparação equivalente aos demais.</a:t>
-            </a:r>
-          </a:p>
-          <a:p>
-            <a:pPr algn="l"/>
-            <a:r>
-              <a:rPr sz="1400" b="0">
-                <a:solidFill>
-                  <a:srgbClr val="2B2B2B"/>
-                </a:solidFill>
-                <a:latin typeface="Calibri"/>
-              </a:rPr>
-              <a:t/>
-            </a:r>
-          </a:p>
-          <a:p>
-            <a:pPr algn="l"/>
-            <a:r>
-              <a:rPr sz="1400" b="0">
-                <a:solidFill>
-                  <a:srgbClr val="2B2B2B"/>
-                </a:solidFill>
-                <a:latin typeface="Calibri"/>
-              </a:rPr>
-              <a:t>A diferença entre os dois grupos é a</a:t>
-            </a:r>
-          </a:p>
-          <a:p>
-            <a:pPr algn="l"/>
-            <a:r>
-              <a:rPr sz="1400" b="0">
-                <a:solidFill>
-                  <a:srgbClr val="2B2B2B"/>
-                </a:solidFill>
-                <a:latin typeface="Calibri"/>
-              </a:rPr>
-              <a:t>venda que o envio causou:</a:t>
-            </a:r>
-          </a:p>
-          <a:p>
-            <a:pPr algn="l"/>
-            <a:r>
-              <a:rPr sz="1400" b="0">
-                <a:solidFill>
-                  <a:srgbClr val="2B2B2B"/>
-                </a:solidFill>
-                <a:latin typeface="Calibri"/>
-              </a:rPr>
-              <a:t>R$ 9,21 por cliente em 7 dias</a:t>
-            </a:r>
-          </a:p>
-          <a:p>
-            <a:pPr algn="l"/>
-            <a:r>
-              <a:rPr sz="1400" b="0">
-                <a:solidFill>
-                  <a:srgbClr val="2B2B2B"/>
-                </a:solidFill>
-                <a:latin typeface="Calibri"/>
-              </a:rPr>
-              <a:t>(intervalo de confiança 8,45–9,90).</a:t>
-            </a:r>
-          </a:p>
-          <a:p>
-            <a:pPr algn="l"/>
-            <a:r>
-              <a:rPr sz="1400" b="0">
-                <a:solidFill>
-                  <a:srgbClr val="2B2B2B"/>
-                </a:solidFill>
-                <a:latin typeface="Calibri"/>
-              </a:rPr>
-              <a:t/>
-            </a:r>
-          </a:p>
-          <a:p>
-            <a:pPr algn="l"/>
-            <a:r>
-              <a:rPr sz="1400" b="0">
-                <a:solidFill>
-                  <a:srgbClr val="2B2B2B"/>
-                </a:solidFill>
-                <a:latin typeface="Calibri"/>
-              </a:rPr>
-              <a:t>Cupons de desconto rendem mais que</a:t>
-            </a:r>
-          </a:p>
-          <a:p>
-            <a:pPr algn="l"/>
-            <a:r>
-              <a:rPr sz="1400" b="0">
-                <a:solidFill>
-                  <a:srgbClr val="2B2B2B"/>
-                </a:solidFill>
-                <a:latin typeface="Calibri"/>
-              </a:rPr>
-              <a:t>BOGO e que ofertas informativas.</a:t>
+              <a:t>Desconto rende 34% mais que BOGO.</a:t>
             </a:r>
           </a:p>
         </p:txBody>
@@ -4073,13 +4143,13 @@
           <a:p>
             <a:pPr algn="l"/>
             <a:r>
-              <a:rPr sz="2700" b="1">
+              <a:rPr sz="2600" b="1">
                 <a:solidFill>
                   <a:srgbClr val="2B2B2B"/>
                 </a:solidFill>
                 <a:latin typeface="Calibri"/>
               </a:rPr>
-              <a:t>Uma política por cliente: a melhor oferta — ou nenhuma</a:t>
+              <a:t>Dá para saber, antes de enviar, em quem a oferta faz diferença</a:t>
             </a:r>
           </a:p>
         </p:txBody>
@@ -4117,7 +4187,7 @@
         <p:spPr>
           <a:xfrm>
             <a:off x="7040880" y="1828800"/>
-            <a:ext cx="4754880" cy="731520"/>
+            <a:ext cx="4846320" cy="640080"/>
           </a:xfrm>
           <a:prstGeom prst="rect">
             <a:avLst/>
@@ -4138,7 +4208,7 @@
                 </a:solidFill>
                 <a:latin typeface="Calibri"/>
               </a:rPr>
-              <a:t>O modelo prioriza quem gera valor</a:t>
+              <a:t>Testado em campanhas futuras</a:t>
             </a:r>
           </a:p>
         </p:txBody>
@@ -4152,7 +4222,7 @@
         <p:spPr>
           <a:xfrm>
             <a:off x="7040880" y="2377440"/>
-            <a:ext cx="4846320" cy="2377440"/>
+            <a:ext cx="4846320" cy="2194560"/>
           </a:xfrm>
           <a:prstGeom prst="rect">
             <a:avLst/>
@@ -4167,61 +4237,73 @@
           <a:p>
             <a:pPr algn="l"/>
             <a:r>
-              <a:rPr sz="1400" b="0">
+              <a:rPr sz="1500" b="0">
                 <a:solidFill>
                   <a:srgbClr val="2B2B2B"/>
                 </a:solidFill>
                 <a:latin typeface="Calibri"/>
               </a:rPr>
-              <a:t>Testado em campanhas futuras (fora da</a:t>
-            </a:r>
-          </a:p>
-          <a:p>
-            <a:pPr algn="l"/>
-            <a:r>
-              <a:rPr sz="1400" b="0">
+              <a:t>O modelo ordena os clientes por</a:t>
+            </a:r>
+          </a:p>
+          <a:p>
+            <a:pPr algn="l"/>
+            <a:r>
+              <a:rPr sz="1500" b="0">
                 <a:solidFill>
                   <a:srgbClr val="2B2B2B"/>
                 </a:solidFill>
                 <a:latin typeface="Calibri"/>
               </a:rPr>
-              <a:t>amostra de treino): o grupo apontado</a:t>
-            </a:r>
-          </a:p>
-          <a:p>
-            <a:pPr algn="l"/>
-            <a:r>
-              <a:rPr sz="1400" b="0">
+              <a:t>quanto a oferta deve render em cada um.</a:t>
+            </a:r>
+          </a:p>
+          <a:p>
+            <a:pPr algn="l"/>
+            <a:r>
+              <a:rPr sz="1500" b="0">
                 <a:solidFill>
                   <a:srgbClr val="2B2B2B"/>
                 </a:solidFill>
                 <a:latin typeface="Calibri"/>
               </a:rPr>
-              <a:t>como prioritário gerou R$ 21 de venda</a:t>
-            </a:r>
-          </a:p>
-          <a:p>
-            <a:pPr algn="l"/>
-            <a:r>
-              <a:rPr sz="1400" b="0">
+              <a:t/>
+            </a:r>
+          </a:p>
+          <a:p>
+            <a:pPr algn="l"/>
+            <a:r>
+              <a:rPr sz="1500" b="0">
                 <a:solidFill>
                   <a:srgbClr val="2B2B2B"/>
                 </a:solidFill>
                 <a:latin typeface="Calibri"/>
               </a:rPr>
-              <a:t>incremental por cliente; o grupo de</a:t>
-            </a:r>
-          </a:p>
-          <a:p>
-            <a:pPr algn="l"/>
-            <a:r>
-              <a:rPr sz="1400" b="0">
+              <a:t>No grupo apontado como prioridade,</a:t>
+            </a:r>
+          </a:p>
+          <a:p>
+            <a:pPr algn="l"/>
+            <a:r>
+              <a:rPr sz="1500" b="0">
                 <a:solidFill>
                   <a:srgbClr val="2B2B2B"/>
                 </a:solidFill>
                 <a:latin typeface="Calibri"/>
               </a:rPr>
-              <a:t>menor prioridade, zero.</a:t>
+              <a:t>o envio gerou R$ 21 por cliente.</a:t>
+            </a:r>
+          </a:p>
+          <a:p>
+            <a:pPr algn="l"/>
+            <a:r>
+              <a:rPr sz="1500" b="0">
+                <a:solidFill>
+                  <a:srgbClr val="2B2B2B"/>
+                </a:solidFill>
+                <a:latin typeface="Calibri"/>
+              </a:rPr>
+              <a:t>No último grupo, zero.</a:t>
             </a:r>
           </a:p>
         </p:txBody>
@@ -4234,8 +4316,8 @@
         </p:nvSpPr>
         <p:spPr>
           <a:xfrm>
-            <a:off x="7040880" y="4297680"/>
-            <a:ext cx="4754880" cy="1463040"/>
+            <a:off x="7040880" y="4572000"/>
+            <a:ext cx="4846320" cy="914400"/>
           </a:xfrm>
           <a:prstGeom prst="rect">
             <a:avLst/>
@@ -4250,25 +4332,72 @@
           <a:p>
             <a:pPr algn="l"/>
             <a:r>
-              <a:rPr sz="1900" b="1">
+              <a:rPr sz="2000" b="1">
                 <a:solidFill>
                   <a:srgbClr val="EA1D2C"/>
                 </a:solidFill>
                 <a:latin typeface="Calibri"/>
               </a:rPr>
-              <a:t>Hoje, só 10% dos clientes</a:t>
-            </a:r>
-          </a:p>
-          <a:p>
-            <a:pPr algn="l"/>
-            <a:r>
-              <a:rPr sz="1900" b="1">
+              <a:t>Hoje, só 10% recebem</a:t>
+            </a:r>
+          </a:p>
+          <a:p>
+            <a:pPr algn="l"/>
+            <a:r>
+              <a:rPr sz="2000" b="1">
                 <a:solidFill>
                   <a:srgbClr val="EA1D2C"/>
                 </a:solidFill>
                 <a:latin typeface="Calibri"/>
               </a:rPr>
-              <a:t>recebem a sua melhor oferta.</a:t>
+              <a:t>a oferta certa para eles</a:t>
+            </a:r>
+          </a:p>
+        </p:txBody>
+      </p:sp>
+      <p:sp>
+        <p:nvSpPr>
+          <p:cNvPr id="9" name="TextBox 8"/>
+          <p:cNvSpPr txBox="1"/>
+          <p:nvPr/>
+        </p:nvSpPr>
+        <p:spPr>
+          <a:xfrm>
+            <a:off x="7040880" y="5669280"/>
+            <a:ext cx="4846320" cy="640080"/>
+          </a:xfrm>
+          <a:prstGeom prst="rect">
+            <a:avLst/>
+          </a:prstGeom>
+          <a:noFill/>
+        </p:spPr>
+        <p:txBody>
+          <a:bodyPr wrap="square">
+            <a:spAutoFit/>
+          </a:bodyPr>
+          <a:lstStyle/>
+          <a:p>
+            <a:pPr algn="l"/>
+            <a:r>
+              <a:rPr sz="1400" b="0">
+                <a:solidFill>
+                  <a:srgbClr val="2B2B2B"/>
+                </a:solidFill>
+                <a:latin typeface="Calibri"/>
+              </a:rPr>
+              <a:t>O maior ganho não é enviar menos —</a:t>
+            </a:r>
+          </a:p>
+          <a:p>
+            <a:pPr algn="l"/>
+            <a:r>
+              <a:rPr sz="1400" b="0">
+                <a:solidFill>
+                  <a:srgbClr val="2B2B2B"/>
+                </a:solidFill>
+                <a:latin typeface="Calibri"/>
+              </a:rPr>
+              <a:t>é enviar melhor.</a:t>
             </a:r>
           </a:p>
         </p:txBody>
@@ -4364,7 +4493,7 @@
                 </a:solidFill>
                 <a:latin typeface="Calibri"/>
               </a:rPr>
-              <a:t>Impacto e próximos passos</a:t>
+              <a:t>A conclusão</a:t>
             </a:r>
           </a:p>
         </p:txBody>
@@ -4393,13 +4522,13 @@
           <a:p>
             <a:pPr algn="l"/>
             <a:r>
-              <a:rPr sz="2700" b="1">
+              <a:rPr sz="2600" b="1">
                 <a:solidFill>
                   <a:srgbClr val="2B2B2B"/>
                 </a:solidFill>
                 <a:latin typeface="Calibri"/>
               </a:rPr>
-              <a:t>De R$ 10,3M para R$ 12,3M por milhão de envios — com upside a testar</a:t>
+              <a:t>Com o mesmo orçamento, 20% mais resultado</a:t>
             </a:r>
           </a:p>
         </p:txBody>
@@ -4420,8 +4549,8 @@
         </p:blipFill>
         <p:spPr>
           <a:xfrm>
-            <a:off x="457200" y="1828800"/>
-            <a:ext cx="6309360" cy="2984157"/>
+            <a:off x="457200" y="1737360"/>
+            <a:ext cx="5852160" cy="2767914"/>
           </a:xfrm>
           <a:prstGeom prst="rect">
             <a:avLst/>
@@ -4436,8 +4565,8 @@
         </p:nvSpPr>
         <p:spPr>
           <a:xfrm>
-            <a:off x="7040880" y="1828800"/>
-            <a:ext cx="4846320" cy="1737360"/>
+            <a:off x="6583680" y="1691640"/>
+            <a:ext cx="5303520" cy="548640"/>
           </a:xfrm>
           <a:prstGeom prst="rect">
             <a:avLst/>
@@ -4452,73 +4581,13 @@
           <a:p>
             <a:pPr algn="l"/>
             <a:r>
-              <a:rPr sz="1400" b="0">
+              <a:rPr sz="1700" b="1">
                 <a:solidFill>
                   <a:srgbClr val="2B2B2B"/>
                 </a:solidFill>
                 <a:latin typeface="Calibri"/>
               </a:rPr>
-              <a:t>+R$ 2,0M (+20%) por 1M de envios já</a:t>
-            </a:r>
-          </a:p>
-          <a:p>
-            <a:pPr algn="l"/>
-            <a:r>
-              <a:rPr sz="1400" b="0">
-                <a:solidFill>
-                  <a:srgbClr val="2B2B2B"/>
-                </a:solidFill>
-                <a:latin typeface="Calibri"/>
-              </a:rPr>
-              <a:t>no cenário conservador, enviando 5%</a:t>
-            </a:r>
-          </a:p>
-          <a:p>
-            <a:pPr algn="l"/>
-            <a:r>
-              <a:rPr sz="1400" b="0">
-                <a:solidFill>
-                  <a:srgbClr val="2B2B2B"/>
-                </a:solidFill>
-                <a:latin typeface="Calibri"/>
-              </a:rPr>
-              <a:t>menos cupons.</a:t>
-            </a:r>
-          </a:p>
-          <a:p>
-            <a:pPr algn="l"/>
-            <a:r>
-              <a:rPr sz="1400" b="0">
-                <a:solidFill>
-                  <a:srgbClr val="2B2B2B"/>
-                </a:solidFill>
-                <a:latin typeface="Calibri"/>
-              </a:rPr>
-              <a:t>Potencial de ~R$ 29M com persona-</a:t>
-            </a:r>
-          </a:p>
-          <a:p>
-            <a:pPr algn="l"/>
-            <a:r>
-              <a:rPr sz="1400" b="0">
-                <a:solidFill>
-                  <a:srgbClr val="2B2B2B"/>
-                </a:solidFill>
-                <a:latin typeface="Calibri"/>
-              </a:rPr>
-              <a:t>lização total — número de modelo, a</a:t>
-            </a:r>
-          </a:p>
-          <a:p>
-            <a:pPr algn="l"/>
-            <a:r>
-              <a:rPr sz="1400" b="0">
-                <a:solidFill>
-                  <a:srgbClr val="2B2B2B"/>
-                </a:solidFill>
-                <a:latin typeface="Calibri"/>
-              </a:rPr>
-              <a:t>confirmar em teste controlado.</a:t>
+              <a:t>O que aprendemos</a:t>
             </a:r>
           </a:p>
         </p:txBody>
@@ -4531,8 +4600,8 @@
         </p:nvSpPr>
         <p:spPr>
           <a:xfrm>
-            <a:off x="7040880" y="3749039"/>
-            <a:ext cx="4754880" cy="548640"/>
+            <a:off x="6583680" y="2240280"/>
+            <a:ext cx="5394960" cy="365760"/>
           </a:xfrm>
           <a:prstGeom prst="rect">
             <a:avLst/>
@@ -4547,13 +4616,13 @@
           <a:p>
             <a:pPr algn="l"/>
             <a:r>
-              <a:rPr sz="1600" b="1">
-                <a:solidFill>
-                  <a:srgbClr val="2B2B2B"/>
-                </a:solidFill>
-                <a:latin typeface="Calibri"/>
-              </a:rPr>
-              <a:t>Próximos passos</a:t>
+              <a:rPr sz="1400" b="1">
+                <a:solidFill>
+                  <a:srgbClr val="EA1D2C"/>
+                </a:solidFill>
+                <a:latin typeface="Calibri"/>
+              </a:rPr>
+              <a:t>1. Cupom funciona — mas não para todos.</a:t>
             </a:r>
           </a:p>
         </p:txBody>
@@ -4566,8 +4635,8 @@
         </p:nvSpPr>
         <p:spPr>
           <a:xfrm>
-            <a:off x="7040880" y="4297680"/>
-            <a:ext cx="4846320" cy="2011680"/>
+            <a:off x="6583680" y="2560320"/>
+            <a:ext cx="5394960" cy="822960"/>
           </a:xfrm>
           <a:prstGeom prst="rect">
             <a:avLst/>
@@ -4582,61 +4651,295 @@
           <a:p>
             <a:pPr algn="l"/>
             <a:r>
-              <a:rPr sz="1400" b="0">
+              <a:rPr sz="1300" b="0">
                 <a:solidFill>
                   <a:srgbClr val="2B2B2B"/>
                 </a:solidFill>
                 <a:latin typeface="Calibri"/>
               </a:rPr>
-              <a:t>1. Teste A/B com grupo de controle</a:t>
-            </a:r>
-          </a:p>
-          <a:p>
-            <a:pPr algn="l"/>
-            <a:r>
-              <a:rPr sz="1400" b="0">
+              <a:t>O efeito médio é positivo, porém vai de R$ 21</a:t>
+            </a:r>
+          </a:p>
+          <a:p>
+            <a:pPr algn="l"/>
+            <a:r>
+              <a:rPr sz="1300" b="0">
                 <a:solidFill>
                   <a:srgbClr val="2B2B2B"/>
                 </a:solidFill>
                 <a:latin typeface="Calibri"/>
               </a:rPr>
-              <a:t>    para confirmar os ganhos</a:t>
-            </a:r>
-          </a:p>
-          <a:p>
-            <a:pPr algn="l"/>
-            <a:r>
-              <a:rPr sz="1400" b="0">
+              <a:t>a zero dependendo da pessoa.</a:t>
+            </a:r>
+          </a:p>
+        </p:txBody>
+      </p:sp>
+      <p:sp>
+        <p:nvSpPr>
+          <p:cNvPr id="9" name="TextBox 8"/>
+          <p:cNvSpPr txBox="1"/>
+          <p:nvPr/>
+        </p:nvSpPr>
+        <p:spPr>
+          <a:xfrm>
+            <a:off x="6583680" y="3474720"/>
+            <a:ext cx="5394960" cy="365760"/>
+          </a:xfrm>
+          <a:prstGeom prst="rect">
+            <a:avLst/>
+          </a:prstGeom>
+          <a:noFill/>
+        </p:spPr>
+        <p:txBody>
+          <a:bodyPr wrap="square">
+            <a:spAutoFit/>
+          </a:bodyPr>
+          <a:lstStyle/>
+          <a:p>
+            <a:pPr algn="l"/>
+            <a:r>
+              <a:rPr sz="1400" b="1">
+                <a:solidFill>
+                  <a:srgbClr val="EA1D2C"/>
+                </a:solidFill>
+                <a:latin typeface="Calibri"/>
+              </a:rPr>
+              <a:t>2. Medir “quem usou o cupom” engana.</a:t>
+            </a:r>
+          </a:p>
+        </p:txBody>
+      </p:sp>
+      <p:sp>
+        <p:nvSpPr>
+          <p:cNvPr id="10" name="TextBox 9"/>
+          <p:cNvSpPr txBox="1"/>
+          <p:nvPr/>
+        </p:nvSpPr>
+        <p:spPr>
+          <a:xfrm>
+            <a:off x="6583680" y="3794760"/>
+            <a:ext cx="5394960" cy="822960"/>
+          </a:xfrm>
+          <a:prstGeom prst="rect">
+            <a:avLst/>
+          </a:prstGeom>
+          <a:noFill/>
+        </p:spPr>
+        <p:txBody>
+          <a:bodyPr wrap="square">
+            <a:spAutoFit/>
+          </a:bodyPr>
+          <a:lstStyle/>
+          <a:p>
+            <a:pPr algn="l"/>
+            <a:r>
+              <a:rPr sz="1300" b="0">
                 <a:solidFill>
                   <a:srgbClr val="2B2B2B"/>
                 </a:solidFill>
                 <a:latin typeface="Calibri"/>
               </a:rPr>
-              <a:t>2. Alocação sob orçamento de cupons</a:t>
-            </a:r>
-          </a:p>
-          <a:p>
-            <a:pPr algn="l"/>
-            <a:r>
-              <a:rPr sz="1400" b="0">
+              <a:t>Quem gasta muito usa cupom de qualquer jeito.</a:t>
+            </a:r>
+          </a:p>
+          <a:p>
+            <a:pPr algn="l"/>
+            <a:r>
+              <a:rPr sz="1300" b="0">
                 <a:solidFill>
                   <a:srgbClr val="2B2B2B"/>
                 </a:solidFill>
                 <a:latin typeface="Calibri"/>
               </a:rPr>
-              <a:t>3. Otimização de timing e canal</a:t>
-            </a:r>
-          </a:p>
-          <a:p>
-            <a:pPr algn="l"/>
-            <a:r>
-              <a:rPr sz="1400" b="0">
+              <a:t>Só comparando com quem não recebeu dá</a:t>
+            </a:r>
+          </a:p>
+          <a:p>
+            <a:pPr algn="l"/>
+            <a:r>
+              <a:rPr sz="1300" b="0">
                 <a:solidFill>
                   <a:srgbClr val="2B2B2B"/>
                 </a:solidFill>
                 <a:latin typeface="Calibri"/>
               </a:rPr>
-              <a:t>4. Integração ao motor de campanhas</a:t>
+              <a:t>para saber o que a oferta causou.</a:t>
+            </a:r>
+          </a:p>
+        </p:txBody>
+      </p:sp>
+      <p:sp>
+        <p:nvSpPr>
+          <p:cNvPr id="11" name="TextBox 10"/>
+          <p:cNvSpPr txBox="1"/>
+          <p:nvPr/>
+        </p:nvSpPr>
+        <p:spPr>
+          <a:xfrm>
+            <a:off x="6583680" y="4709160"/>
+            <a:ext cx="5394960" cy="365760"/>
+          </a:xfrm>
+          <a:prstGeom prst="rect">
+            <a:avLst/>
+          </a:prstGeom>
+          <a:noFill/>
+        </p:spPr>
+        <p:txBody>
+          <a:bodyPr wrap="square">
+            <a:spAutoFit/>
+          </a:bodyPr>
+          <a:lstStyle/>
+          <a:p>
+            <a:pPr algn="l"/>
+            <a:r>
+              <a:rPr sz="1400" b="1">
+                <a:solidFill>
+                  <a:srgbClr val="EA1D2C"/>
+                </a:solidFill>
+                <a:latin typeface="Calibri"/>
+              </a:rPr>
+              <a:t>3. O dinheiro está em acertar o alvo.</a:t>
+            </a:r>
+          </a:p>
+        </p:txBody>
+      </p:sp>
+      <p:sp>
+        <p:nvSpPr>
+          <p:cNvPr id="12" name="TextBox 11"/>
+          <p:cNvSpPr txBox="1"/>
+          <p:nvPr/>
+        </p:nvSpPr>
+        <p:spPr>
+          <a:xfrm>
+            <a:off x="6583680" y="5029200"/>
+            <a:ext cx="5394960" cy="822960"/>
+          </a:xfrm>
+          <a:prstGeom prst="rect">
+            <a:avLst/>
+          </a:prstGeom>
+          <a:noFill/>
+        </p:spPr>
+        <p:txBody>
+          <a:bodyPr wrap="square">
+            <a:spAutoFit/>
+          </a:bodyPr>
+          <a:lstStyle/>
+          <a:p>
+            <a:pPr algn="l"/>
+            <a:r>
+              <a:rPr sz="1300" b="0">
+                <a:solidFill>
+                  <a:srgbClr val="2B2B2B"/>
+                </a:solidFill>
+                <a:latin typeface="Calibri"/>
+              </a:rPr>
+              <a:t>Não em cortar envios: 90% recebem a oferta</a:t>
+            </a:r>
+          </a:p>
+          <a:p>
+            <a:pPr algn="l"/>
+            <a:r>
+              <a:rPr sz="1300" b="0">
+                <a:solidFill>
+                  <a:srgbClr val="2B2B2B"/>
+                </a:solidFill>
+                <a:latin typeface="Calibri"/>
+              </a:rPr>
+              <a:t>errada, e corrigir isso rende +20%.</a:t>
+            </a:r>
+          </a:p>
+        </p:txBody>
+      </p:sp>
+      <p:sp>
+        <p:nvSpPr>
+          <p:cNvPr id="13" name="TextBox 12"/>
+          <p:cNvSpPr txBox="1"/>
+          <p:nvPr/>
+        </p:nvSpPr>
+        <p:spPr>
+          <a:xfrm>
+            <a:off x="548640" y="5806440"/>
+            <a:ext cx="5852160" cy="914400"/>
+          </a:xfrm>
+          <a:prstGeom prst="rect">
+            <a:avLst/>
+          </a:prstGeom>
+          <a:noFill/>
+        </p:spPr>
+        <p:txBody>
+          <a:bodyPr wrap="square">
+            <a:spAutoFit/>
+          </a:bodyPr>
+          <a:lstStyle/>
+          <a:p>
+            <a:pPr algn="l"/>
+            <a:r>
+              <a:rPr sz="1200" b="0">
+                <a:solidFill>
+                  <a:srgbClr val="666666"/>
+                </a:solidFill>
+                <a:latin typeface="Calibri"/>
+              </a:rPr>
+              <a:t>Por 1 milhão de envios: de R$ 10,3M para R$ 12,3M.</a:t>
+            </a:r>
+          </a:p>
+          <a:p>
+            <a:pPr algn="l"/>
+            <a:r>
+              <a:rPr sz="1200" b="0">
+                <a:solidFill>
+                  <a:srgbClr val="666666"/>
+                </a:solidFill>
+                <a:latin typeface="Calibri"/>
+              </a:rPr>
+              <a:t>Há potencial maior com personalização total — número de modelo,</a:t>
+            </a:r>
+          </a:p>
+          <a:p>
+            <a:pPr algn="l"/>
+            <a:r>
+              <a:rPr sz="1200" b="0">
+                <a:solidFill>
+                  <a:srgbClr val="666666"/>
+                </a:solidFill>
+                <a:latin typeface="Calibri"/>
+              </a:rPr>
+              <a:t>a confirmar em teste A/B.</a:t>
+            </a:r>
+          </a:p>
+        </p:txBody>
+      </p:sp>
+      <p:sp>
+        <p:nvSpPr>
+          <p:cNvPr id="14" name="TextBox 13"/>
+          <p:cNvSpPr txBox="1"/>
+          <p:nvPr/>
+        </p:nvSpPr>
+        <p:spPr>
+          <a:xfrm>
+            <a:off x="6583680" y="5943600"/>
+            <a:ext cx="5394960" cy="548640"/>
+          </a:xfrm>
+          <a:prstGeom prst="rect">
+            <a:avLst/>
+          </a:prstGeom>
+          <a:noFill/>
+        </p:spPr>
+        <p:txBody>
+          <a:bodyPr wrap="square">
+            <a:spAutoFit/>
+          </a:bodyPr>
+          <a:lstStyle/>
+          <a:p>
+            <a:pPr algn="l"/>
+            <a:r>
+              <a:rPr sz="1400" b="1">
+                <a:solidFill>
+                  <a:srgbClr val="2B2B2B"/>
+                </a:solidFill>
+                <a:latin typeface="Calibri"/>
+              </a:rPr>
+              <a:t>Próximo passo: teste A/B com grupo de controle.</a:t>
             </a:r>
           </a:p>
         </p:txBody>

</xml_diff>

<commit_message>
Corrige rotulo impreciso "piso model-free" e explicita quanto depende do modelo
O piso nao e totalmente model-free: usa o modelo para descartar os ~5% de
efeito previsto <= 0. Mas esse uso REDUZ a projecao em R$667 mil -- sem
modelo algum, so trocando o mix, o numero seria R$12,99M (+26%) em vez de
R$12,32M (+20%). O ganho do piso vem de uma diferenca medida (desconto
rende mais que bogo), nao de previsao.

- rotulos: "piso (model-free)" -> "piso (ganho medido)"; "teto
  (model-based)" -> "teto (depende do modelo)"
- NB2 agora imprime a decomposicao explicita do piso com e sem modelo
- explicitado que a validacao por faixas prova o ranking ENTRE CLIENTES,
  mas nao a TROCA DE OFERTA (cada cliente so recebeu uma) -- e por isso
  que o teto exige A/B
- maldicao do vencedor explicada: argmax de 10 previsoes ruidosas infla o
  maximo mesmo quando as ofertas tem efeito identico
- deck e presentation.md alinhados

Co-Authored-By: Claude Fable 5 <noreply@anthropic.com>
</commit_message>
<xml_diff>
--- a/presentation/ifood_case.pptx
+++ b/presentation/ifood_case.pptx
@@ -4550,7 +4550,7 @@
         <p:spPr>
           <a:xfrm>
             <a:off x="457200" y="1737360"/>
-            <a:ext cx="5852160" cy="2767914"/>
+            <a:ext cx="5852160" cy="2819877"/>
           </a:xfrm>
           <a:prstGeom prst="rect">
             <a:avLst/>
@@ -4880,7 +4880,7 @@
                 </a:solidFill>
                 <a:latin typeface="Calibri"/>
               </a:rPr>
-              <a:t>Por 1 milhão de envios: de R$ 10,3M para R$ 12,3M.</a:t>
+              <a:t>Por 1 milhão de envios: de R$ 10,3M para R$ 12,3M — ganho baseado numa</a:t>
             </a:r>
           </a:p>
           <a:p>
@@ -4892,7 +4892,7 @@
                 </a:solidFill>
                 <a:latin typeface="Calibri"/>
               </a:rPr>
-              <a:t>Há potencial maior com personalização total — número de modelo,</a:t>
+              <a:t>diferença já medida (desconto rende mais que BOGO). O potencial maior depende</a:t>
             </a:r>
           </a:p>
           <a:p>
@@ -4904,7 +4904,7 @@
                 </a:solidFill>
                 <a:latin typeface="Calibri"/>
               </a:rPr>
-              <a:t>a confirmar em teste A/B.</a:t>
+              <a:t>de o modelo acertar a oferta de cada pessoa, e por isso precisa de teste A/B.</a:t>
             </a:r>
           </a:p>
         </p:txBody>

</xml_diff>